<commit_message>
Articulo v9 (matriz de confusion y diagramas), PPT de avance y scripts actualizados
Incluye la matriz de confusion corregida (FP y FN estaban intercambiados en la imagen),
los diagramas ETL y de generacion de clips, y el enlace del repositorio en el articulo.

Co-Authored-By: Claude Sonnet 5.5 <noreply@anthropic.com>
</commit_message>
<xml_diff>
--- a/resultados/Avance_Pipeline_y_Resultados.pptx
+++ b/resultados/Avance_Pipeline_y_Resultados.pptx
@@ -21,9 +21,10 @@
     <p:sldId id="269" r:id="rId15"/>
     <p:sldId id="270" r:id="rId16"/>
     <p:sldId id="271" r:id="rId17"/>
+    <p:sldId id="272" r:id="rId18"/>
   </p:sldIdLst>
   <p:notesMasterIdLst>
-    <p:notesMasterId r:id="rId18"/>
+    <p:notesMasterId r:id="rId19"/>
   </p:notesMasterIdLst>
   <p:sldSz cx="9144000" cy="5143500"/>
   <p:notesSz cx="5143500" cy="9144000"/>
@@ -2629,7 +2630,7 @@
           <a:p>
             <a:r>
               <a:rPr lang="en-US" dirty="0"/>
-              <a:t>Cada paso se escribió como hipótesis, se probó en videos no vistos y se registró. Lo que no mejoró también quedó documentado.</a:t>
+              <a:t>557 videos no usados para fijar la fórmula, solo contenido, 5 clips por video. Duplica la precisión del azar, pero la cobertura es baja porque solo se eligen 5 ventanas.</a:t>
             </a:r>
             <a:endParaRPr lang="en-US" dirty="0"/>
           </a:p>
@@ -2717,7 +2718,7 @@
           <a:p>
             <a:r>
               <a:rPr lang="en-US" dirty="0"/>
-              <a:t>Son de los mejores casos de 548. Lo típico es 56 % con al menos un acierto. Sirven para mostrar cómo se explica cada clip.</a:t>
+              <a:t>Cada paso se escribió como hipótesis, se probó en videos no vistos y se registró. Lo que no mejoró también quedó documentado.</a:t>
             </a:r>
             <a:endParaRPr lang="en-US" dirty="0"/>
           </a:p>
@@ -2805,7 +2806,7 @@
           <a:p>
             <a:r>
               <a:rPr lang="en-US" dirty="0"/>
-              <a:t>Calor real de YouTube y los 5 clips elegidos solo con contenido. 4 de 5 caen sobre un pico real.</a:t>
+              <a:t>Son de los mejores casos de 548. Lo típico es 56 % con al menos un acierto. Sirven para mostrar cómo se explica cada clip.</a:t>
             </a:r>
             <a:endParaRPr lang="en-US" dirty="0"/>
           </a:p>
@@ -2893,7 +2894,7 @@
           <a:p>
             <a:r>
               <a:rPr lang="en-US" dirty="0"/>
-              <a:t>Calor real de YouTube y los 5 clips elegidos solo con contenido. 3 de 5 caen sobre un pico real.</a:t>
+              <a:t>Calor real de YouTube y los 5 clips elegidos solo con contenido. 4 de 5 caen sobre un pico real.</a:t>
             </a:r>
             <a:endParaRPr lang="en-US" dirty="0"/>
           </a:p>
@@ -3069,7 +3070,7 @@
           <a:p>
             <a:r>
               <a:rPr lang="en-US" dirty="0"/>
-              <a:t>El techo con solo contenido está en 50–69 %. Para pasar de ahí haría falta información que no está en el video.</a:t>
+              <a:t>Calor real de YouTube y los 5 clips elegidos solo con contenido. 3 de 5 caen sobre un pico real.</a:t>
             </a:r>
             <a:endParaRPr lang="en-US" dirty="0"/>
           </a:p>
@@ -3093,6 +3094,94 @@
             <a:fld id="{F7021451-1387-4CA6-816F-3879F97B5CBC}" type="slidenum">
               <a:rPr lang="en-US"/>
               <a:t>16</a:t>
+            </a:fld>
+            <a:endParaRPr lang="en-US"/>
+          </a:p>
+        </p:txBody>
+      </p:sp>
+    </p:spTree>
+    <p:extLst>
+      <p:ext uri="{BB962C8B-B14F-4D97-AF65-F5344CB8AC3E}">
+        <p14:creationId xmlns:p14="http://schemas.microsoft.com/office/powerpoint/2010/main" val="1024086991"/>
+      </p:ext>
+    </p:extLst>
+  </p:cSld>
+  <p:clrMapOvr>
+    <a:masterClrMapping/>
+  </p:clrMapOvr>
+</p:notes>
+</file>
+
+<file path=ppt/notesSlides/notesSlide17.xml><?xml version="1.0" encoding="utf-8"?>
+<p:notes xmlns:a="http://schemas.openxmlformats.org/drawingml/2006/main" xmlns:r="http://schemas.openxmlformats.org/officeDocument/2006/relationships" xmlns:p="http://schemas.openxmlformats.org/presentationml/2006/main">
+  <p:cSld>
+    <p:spTree>
+      <p:nvGrpSpPr>
+        <p:cNvPr id="1" name=""/>
+        <p:cNvGrpSpPr/>
+        <p:nvPr/>
+      </p:nvGrpSpPr>
+      <p:grpSpPr>
+        <a:xfrm>
+          <a:off x="0" y="0"/>
+          <a:ext cx="0" cy="0"/>
+          <a:chOff x="0" y="0"/>
+          <a:chExt cx="0" cy="0"/>
+        </a:xfrm>
+      </p:grpSpPr>
+      <p:sp>
+        <p:nvSpPr>
+          <p:cNvPr id="2" name="Slide Image Placeholder 1"/>
+          <p:cNvSpPr>
+            <a:spLocks noGrp="1" noRot="1" noChangeAspect="1"/>
+          </p:cNvSpPr>
+          <p:nvPr>
+            <p:ph type="sldImg"/>
+          </p:nvPr>
+        </p:nvSpPr>
+        <p:spPr/>
+      </p:sp>
+      <p:sp>
+        <p:nvSpPr>
+          <p:cNvPr id="3" name="Notes Placeholder 2"/>
+          <p:cNvSpPr>
+            <a:spLocks noGrp="1"/>
+          </p:cNvSpPr>
+          <p:nvPr>
+            <p:ph type="body" idx="1"/>
+          </p:nvPr>
+        </p:nvSpPr>
+        <p:spPr/>
+        <p:txBody>
+          <a:bodyPr/>
+          <a:lstStyle/>
+          <a:p>
+            <a:r>
+              <a:rPr lang="en-US" dirty="0"/>
+              <a:t>El techo con solo contenido está en 50–69 %. Para pasar de ahí haría falta información que no está en el video.</a:t>
+            </a:r>
+            <a:endParaRPr lang="en-US" dirty="0"/>
+          </a:p>
+        </p:txBody>
+      </p:sp>
+      <p:sp>
+        <p:nvSpPr>
+          <p:cNvPr id="4" name="Slide Number Placeholder 3"/>
+          <p:cNvSpPr>
+            <a:spLocks noGrp="1"/>
+          </p:cNvSpPr>
+          <p:nvPr>
+            <p:ph type="sldNum" sz="quarter" idx="10"/>
+          </p:nvPr>
+        </p:nvSpPr>
+        <p:spPr/>
+        <p:txBody>
+          <a:bodyPr/>
+          <a:lstStyle/>
+          <a:p>
+            <a:fld id="{F7021451-1387-4CA6-816F-3879F97B5CBC}" type="slidenum">
+              <a:rPr lang="en-US"/>
+              <a:t>17</a:t>
             </a:fld>
             <a:endParaRPr lang="en-US"/>
           </a:p>
@@ -5095,7 +5184,7 @@
                 <a:ea typeface="Verdana" pitchFamily="34" charset="-122"/>
                 <a:cs typeface="Verdana" pitchFamily="34" charset="-120"/>
               </a:rPr>
-              <a:t>Cómo pasamos de azar a más de 60 %</a:t>
+              <a:t>Matriz de confusión por ventana</a:t>
             </a:r>
             <a:endParaRPr lang="en-US" sz="2200" dirty="0"/>
           </a:p>
@@ -5207,6 +5296,1236 @@
       <p:graphicFrame>
         <p:nvGraphicFramePr>
           <p:cNvPr id="12" name="Table 0"/>
+          <p:cNvGraphicFramePr>
+            <a:graphicFrameLocks noGrp="1"/>
+          </p:cNvGraphicFramePr>
+          <p:nvPr>
+            <p:extLst>
+              <p:ext uri="{D42A27DB-BD31-4B8C-83A1-F6EECF244321}">
+                <p14:modId xmlns:p14="http://schemas.microsoft.com/office/powerpoint/2010/main" val="1579011935"/>
+              </p:ext>
+            </p:extLst>
+          </p:nvPr>
+        </p:nvGraphicFramePr>
+        <p:xfrm>
+          <a:off x="457200" y="1463040"/>
+          <a:ext cx="4846320" cy="914400"/>
+        </p:xfrm>
+        <a:graphic>
+          <a:graphicData uri="http://schemas.openxmlformats.org/drawingml/2006/table">
+            <a:tbl>
+              <a:tblPr/>
+              <a:tblGrid>
+                <a:gridCol w="1554480"/>
+                <a:gridCol w="1645920"/>
+                <a:gridCol w="1645920"/>
+              </a:tblGrid>
+              <a:tr h="411480">
+                <a:tc>
+                  <a:txBody>
+                    <a:bodyPr/>
+                    <a:lstStyle/>
+                    <a:p>
+                      <a:pPr algn="ctr" indent="0" marL="0">
+                        <a:buNone/>
+                      </a:pPr>
+                      <a:endParaRPr lang="en-US" sz="1100" dirty="0">
+                        <a:latin typeface="Verdana" charset="0"/>
+                        <a:ea typeface="Verdana" charset="0"/>
+                        <a:cs typeface="Verdana" charset="0"/>
+                      </a:endParaRPr>
+                    </a:p>
+                  </a:txBody>
+                  <a:tcPr marL="91440" marR="91440" marT="45720" marB="45720" anchor="ctr">
+                    <a:lnL w="9525" cap="flat" cmpd="sng" algn="ctr">
+                      <a:solidFill>
+                        <a:srgbClr val="D0D0D0"/>
+                      </a:solidFill>
+                      <a:prstDash val="solid"/>
+                      <a:round/>
+                      <a:headEnd type="none" w="med" len="med"/>
+                      <a:tailEnd type="none" w="med" len="med"/>
+                    </a:lnL>
+                    <a:lnR w="9525" cap="flat" cmpd="sng" algn="ctr">
+                      <a:solidFill>
+                        <a:srgbClr val="D0D0D0"/>
+                      </a:solidFill>
+                      <a:prstDash val="solid"/>
+                      <a:round/>
+                      <a:headEnd type="none" w="med" len="med"/>
+                      <a:tailEnd type="none" w="med" len="med"/>
+                    </a:lnR>
+                    <a:lnT w="9525" cap="flat" cmpd="sng" algn="ctr">
+                      <a:solidFill>
+                        <a:srgbClr val="D0D0D0"/>
+                      </a:solidFill>
+                      <a:prstDash val="solid"/>
+                      <a:round/>
+                      <a:headEnd type="none" w="med" len="med"/>
+                      <a:tailEnd type="none" w="med" len="med"/>
+                    </a:lnT>
+                    <a:lnB w="9525" cap="flat" cmpd="sng" algn="ctr">
+                      <a:solidFill>
+                        <a:srgbClr val="D0D0D0"/>
+                      </a:solidFill>
+                      <a:prstDash val="solid"/>
+                      <a:round/>
+                      <a:headEnd type="none" w="med" len="med"/>
+                      <a:tailEnd type="none" w="med" len="med"/>
+                    </a:lnB>
+                    <a:solidFill>
+                      <a:srgbClr val="F2F2F2"/>
+                    </a:solidFill>
+                  </a:tcPr>
+                </a:tc>
+                <a:tc>
+                  <a:txBody>
+                    <a:bodyPr/>
+                    <a:lstStyle/>
+                    <a:p>
+                      <a:pPr algn="ctr" indent="0" marL="0">
+                        <a:buNone/>
+                      </a:pPr>
+                      <a:r>
+                        <a:rPr lang="en-US" sz="1100" b="1" dirty="0">
+                          <a:solidFill>
+                            <a:srgbClr val="000000"/>
+                          </a:solidFill>
+                          <a:latin typeface="Verdana" pitchFamily="34" charset="0"/>
+                          <a:ea typeface="Verdana" pitchFamily="34" charset="-122"/>
+                          <a:cs typeface="Verdana" pitchFamily="34" charset="-120"/>
+                        </a:rPr>
+                        <a:t>Caliente (pico real)</a:t>
+                      </a:r>
+                      <a:endParaRPr lang="en-US" sz="1100" dirty="0">
+                        <a:latin typeface="Verdana" charset="0"/>
+                        <a:ea typeface="Verdana" charset="0"/>
+                        <a:cs typeface="Verdana" charset="0"/>
+                      </a:endParaRPr>
+                    </a:p>
+                  </a:txBody>
+                  <a:tcPr marL="91440" marR="91440" marT="45720" marB="45720" anchor="ctr">
+                    <a:lnL w="9525" cap="flat" cmpd="sng" algn="ctr">
+                      <a:solidFill>
+                        <a:srgbClr val="D0D0D0"/>
+                      </a:solidFill>
+                      <a:prstDash val="solid"/>
+                      <a:round/>
+                      <a:headEnd type="none" w="med" len="med"/>
+                      <a:tailEnd type="none" w="med" len="med"/>
+                    </a:lnL>
+                    <a:lnR w="9525" cap="flat" cmpd="sng" algn="ctr">
+                      <a:solidFill>
+                        <a:srgbClr val="D0D0D0"/>
+                      </a:solidFill>
+                      <a:prstDash val="solid"/>
+                      <a:round/>
+                      <a:headEnd type="none" w="med" len="med"/>
+                      <a:tailEnd type="none" w="med" len="med"/>
+                    </a:lnR>
+                    <a:lnT w="9525" cap="flat" cmpd="sng" algn="ctr">
+                      <a:solidFill>
+                        <a:srgbClr val="D0D0D0"/>
+                      </a:solidFill>
+                      <a:prstDash val="solid"/>
+                      <a:round/>
+                      <a:headEnd type="none" w="med" len="med"/>
+                      <a:tailEnd type="none" w="med" len="med"/>
+                    </a:lnT>
+                    <a:lnB w="9525" cap="flat" cmpd="sng" algn="ctr">
+                      <a:solidFill>
+                        <a:srgbClr val="D0D0D0"/>
+                      </a:solidFill>
+                      <a:prstDash val="solid"/>
+                      <a:round/>
+                      <a:headEnd type="none" w="med" len="med"/>
+                      <a:tailEnd type="none" w="med" len="med"/>
+                    </a:lnB>
+                    <a:solidFill>
+                      <a:srgbClr val="F2F2F2"/>
+                    </a:solidFill>
+                  </a:tcPr>
+                </a:tc>
+                <a:tc>
+                  <a:txBody>
+                    <a:bodyPr/>
+                    <a:lstStyle/>
+                    <a:p>
+                      <a:pPr algn="ctr" indent="0" marL="0">
+                        <a:buNone/>
+                      </a:pPr>
+                      <a:r>
+                        <a:rPr lang="en-US" sz="1100" b="1" dirty="0">
+                          <a:solidFill>
+                            <a:srgbClr val="000000"/>
+                          </a:solidFill>
+                          <a:latin typeface="Verdana" pitchFamily="34" charset="0"/>
+                          <a:ea typeface="Verdana" pitchFamily="34" charset="-122"/>
+                          <a:cs typeface="Verdana" pitchFamily="34" charset="-120"/>
+                        </a:rPr>
+                        <a:t>No caliente</a:t>
+                      </a:r>
+                      <a:endParaRPr lang="en-US" sz="1100" dirty="0">
+                        <a:latin typeface="Verdana" charset="0"/>
+                        <a:ea typeface="Verdana" charset="0"/>
+                        <a:cs typeface="Verdana" charset="0"/>
+                      </a:endParaRPr>
+                    </a:p>
+                  </a:txBody>
+                  <a:tcPr marL="91440" marR="91440" marT="45720" marB="45720" anchor="ctr">
+                    <a:lnL w="9525" cap="flat" cmpd="sng" algn="ctr">
+                      <a:solidFill>
+                        <a:srgbClr val="D0D0D0"/>
+                      </a:solidFill>
+                      <a:prstDash val="solid"/>
+                      <a:round/>
+                      <a:headEnd type="none" w="med" len="med"/>
+                      <a:tailEnd type="none" w="med" len="med"/>
+                    </a:lnL>
+                    <a:lnR w="9525" cap="flat" cmpd="sng" algn="ctr">
+                      <a:solidFill>
+                        <a:srgbClr val="D0D0D0"/>
+                      </a:solidFill>
+                      <a:prstDash val="solid"/>
+                      <a:round/>
+                      <a:headEnd type="none" w="med" len="med"/>
+                      <a:tailEnd type="none" w="med" len="med"/>
+                    </a:lnR>
+                    <a:lnT w="9525" cap="flat" cmpd="sng" algn="ctr">
+                      <a:solidFill>
+                        <a:srgbClr val="D0D0D0"/>
+                      </a:solidFill>
+                      <a:prstDash val="solid"/>
+                      <a:round/>
+                      <a:headEnd type="none" w="med" len="med"/>
+                      <a:tailEnd type="none" w="med" len="med"/>
+                    </a:lnT>
+                    <a:lnB w="9525" cap="flat" cmpd="sng" algn="ctr">
+                      <a:solidFill>
+                        <a:srgbClr val="D0D0D0"/>
+                      </a:solidFill>
+                      <a:prstDash val="solid"/>
+                      <a:round/>
+                      <a:headEnd type="none" w="med" len="med"/>
+                      <a:tailEnd type="none" w="med" len="med"/>
+                    </a:lnB>
+                    <a:solidFill>
+                      <a:srgbClr val="F2F2F2"/>
+                    </a:solidFill>
+                  </a:tcPr>
+                </a:tc>
+              </a:tr>
+              <a:tr h="868680">
+                <a:tc>
+                  <a:txBody>
+                    <a:bodyPr/>
+                    <a:lstStyle/>
+                    <a:p>
+                      <a:pPr algn="ctr" indent="0" marL="0">
+                        <a:buNone/>
+                      </a:pPr>
+                      <a:r>
+                        <a:rPr lang="en-US" sz="1100" b="1" dirty="0">
+                          <a:solidFill>
+                            <a:srgbClr val="000000"/>
+                          </a:solidFill>
+                          <a:latin typeface="Verdana" pitchFamily="34" charset="0"/>
+                          <a:ea typeface="Verdana" pitchFamily="34" charset="-122"/>
+                          <a:cs typeface="Verdana" pitchFamily="34" charset="-120"/>
+                        </a:rPr>
+                        <a:t>Elegido (top 5)</a:t>
+                      </a:r>
+                      <a:endParaRPr lang="en-US" sz="1100" dirty="0">
+                        <a:latin typeface="Verdana" charset="0"/>
+                        <a:ea typeface="Verdana" charset="0"/>
+                        <a:cs typeface="Verdana" charset="0"/>
+                      </a:endParaRPr>
+                    </a:p>
+                  </a:txBody>
+                  <a:tcPr marL="91440" marR="91440" marT="45720" marB="45720" anchor="ctr">
+                    <a:lnL w="9525" cap="flat" cmpd="sng" algn="ctr">
+                      <a:solidFill>
+                        <a:srgbClr val="D0D0D0"/>
+                      </a:solidFill>
+                      <a:prstDash val="solid"/>
+                      <a:round/>
+                      <a:headEnd type="none" w="med" len="med"/>
+                      <a:tailEnd type="none" w="med" len="med"/>
+                    </a:lnL>
+                    <a:lnR w="9525" cap="flat" cmpd="sng" algn="ctr">
+                      <a:solidFill>
+                        <a:srgbClr val="D0D0D0"/>
+                      </a:solidFill>
+                      <a:prstDash val="solid"/>
+                      <a:round/>
+                      <a:headEnd type="none" w="med" len="med"/>
+                      <a:tailEnd type="none" w="med" len="med"/>
+                    </a:lnR>
+                    <a:lnT w="9525" cap="flat" cmpd="sng" algn="ctr">
+                      <a:solidFill>
+                        <a:srgbClr val="D0D0D0"/>
+                      </a:solidFill>
+                      <a:prstDash val="solid"/>
+                      <a:round/>
+                      <a:headEnd type="none" w="med" len="med"/>
+                      <a:tailEnd type="none" w="med" len="med"/>
+                    </a:lnT>
+                    <a:lnB w="9525" cap="flat" cmpd="sng" algn="ctr">
+                      <a:solidFill>
+                        <a:srgbClr val="D0D0D0"/>
+                      </a:solidFill>
+                      <a:prstDash val="solid"/>
+                      <a:round/>
+                      <a:headEnd type="none" w="med" len="med"/>
+                      <a:tailEnd type="none" w="med" len="med"/>
+                    </a:lnB>
+                    <a:solidFill>
+                      <a:srgbClr val="F2F2F2"/>
+                    </a:solidFill>
+                  </a:tcPr>
+                </a:tc>
+                <a:tc>
+                  <a:txBody>
+                    <a:bodyPr/>
+                    <a:lstStyle/>
+                    <a:p>
+                      <a:pPr algn="ctr" indent="0" marL="0">
+                        <a:buNone/>
+                      </a:pPr>
+                      <a:r>
+                        <a:rPr lang="en-US" sz="1800" b="1" dirty="0">
+                          <a:solidFill>
+                            <a:srgbClr val="FFFFFF"/>
+                          </a:solidFill>
+                          <a:latin typeface="Verdana" pitchFamily="34" charset="0"/>
+                          <a:ea typeface="Verdana" pitchFamily="34" charset="-122"/>
+                          <a:cs typeface="Verdana" pitchFamily="34" charset="-120"/>
+                        </a:rPr>
+                        <a:t>468</a:t>
+                      </a:r>
+                      <a:endParaRPr lang="en-US" sz="1800" dirty="0">
+                        <a:latin typeface="Verdana" charset="0"/>
+                        <a:ea typeface="Verdana" charset="0"/>
+                        <a:cs typeface="Verdana" charset="0"/>
+                      </a:endParaRPr>
+                    </a:p>
+                  </a:txBody>
+                  <a:tcPr marL="91440" marR="91440" marT="45720" marB="45720" anchor="ctr">
+                    <a:lnL w="9525" cap="flat" cmpd="sng" algn="ctr">
+                      <a:solidFill>
+                        <a:srgbClr val="D0D0D0"/>
+                      </a:solidFill>
+                      <a:prstDash val="solid"/>
+                      <a:round/>
+                      <a:headEnd type="none" w="med" len="med"/>
+                      <a:tailEnd type="none" w="med" len="med"/>
+                    </a:lnL>
+                    <a:lnR w="9525" cap="flat" cmpd="sng" algn="ctr">
+                      <a:solidFill>
+                        <a:srgbClr val="D0D0D0"/>
+                      </a:solidFill>
+                      <a:prstDash val="solid"/>
+                      <a:round/>
+                      <a:headEnd type="none" w="med" len="med"/>
+                      <a:tailEnd type="none" w="med" len="med"/>
+                    </a:lnR>
+                    <a:lnT w="9525" cap="flat" cmpd="sng" algn="ctr">
+                      <a:solidFill>
+                        <a:srgbClr val="D0D0D0"/>
+                      </a:solidFill>
+                      <a:prstDash val="solid"/>
+                      <a:round/>
+                      <a:headEnd type="none" w="med" len="med"/>
+                      <a:tailEnd type="none" w="med" len="med"/>
+                    </a:lnT>
+                    <a:lnB w="9525" cap="flat" cmpd="sng" algn="ctr">
+                      <a:solidFill>
+                        <a:srgbClr val="D0D0D0"/>
+                      </a:solidFill>
+                      <a:prstDash val="solid"/>
+                      <a:round/>
+                      <a:headEnd type="none" w="med" len="med"/>
+                      <a:tailEnd type="none" w="med" len="med"/>
+                    </a:lnB>
+                    <a:solidFill>
+                      <a:srgbClr val="FF4713"/>
+                    </a:solidFill>
+                  </a:tcPr>
+                </a:tc>
+                <a:tc>
+                  <a:txBody>
+                    <a:bodyPr/>
+                    <a:lstStyle/>
+                    <a:p>
+                      <a:pPr algn="ctr" indent="0" marL="0">
+                        <a:buNone/>
+                      </a:pPr>
+                      <a:r>
+                        <a:rPr lang="en-US" sz="1800" b="1" dirty="0">
+                          <a:solidFill>
+                            <a:srgbClr val="000000"/>
+                          </a:solidFill>
+                          <a:latin typeface="Verdana" pitchFamily="34" charset="0"/>
+                          <a:ea typeface="Verdana" pitchFamily="34" charset="-122"/>
+                          <a:cs typeface="Verdana" pitchFamily="34" charset="-120"/>
+                        </a:rPr>
+                        <a:t>2 317</a:t>
+                      </a:r>
+                      <a:endParaRPr lang="en-US" sz="1800" dirty="0">
+                        <a:latin typeface="Verdana" charset="0"/>
+                        <a:ea typeface="Verdana" charset="0"/>
+                        <a:cs typeface="Verdana" charset="0"/>
+                      </a:endParaRPr>
+                    </a:p>
+                  </a:txBody>
+                  <a:tcPr marL="91440" marR="91440" marT="45720" marB="45720" anchor="ctr">
+                    <a:lnL w="9525" cap="flat" cmpd="sng" algn="ctr">
+                      <a:solidFill>
+                        <a:srgbClr val="D0D0D0"/>
+                      </a:solidFill>
+                      <a:prstDash val="solid"/>
+                      <a:round/>
+                      <a:headEnd type="none" w="med" len="med"/>
+                      <a:tailEnd type="none" w="med" len="med"/>
+                    </a:lnL>
+                    <a:lnR w="9525" cap="flat" cmpd="sng" algn="ctr">
+                      <a:solidFill>
+                        <a:srgbClr val="D0D0D0"/>
+                      </a:solidFill>
+                      <a:prstDash val="solid"/>
+                      <a:round/>
+                      <a:headEnd type="none" w="med" len="med"/>
+                      <a:tailEnd type="none" w="med" len="med"/>
+                    </a:lnR>
+                    <a:lnT w="9525" cap="flat" cmpd="sng" algn="ctr">
+                      <a:solidFill>
+                        <a:srgbClr val="D0D0D0"/>
+                      </a:solidFill>
+                      <a:prstDash val="solid"/>
+                      <a:round/>
+                      <a:headEnd type="none" w="med" len="med"/>
+                      <a:tailEnd type="none" w="med" len="med"/>
+                    </a:lnT>
+                    <a:lnB w="9525" cap="flat" cmpd="sng" algn="ctr">
+                      <a:solidFill>
+                        <a:srgbClr val="D0D0D0"/>
+                      </a:solidFill>
+                      <a:prstDash val="solid"/>
+                      <a:round/>
+                      <a:headEnd type="none" w="med" len="med"/>
+                      <a:tailEnd type="none" w="med" len="med"/>
+                    </a:lnB>
+                    <a:solidFill>
+                      <a:srgbClr val="FFFFFF"/>
+                    </a:solidFill>
+                  </a:tcPr>
+                </a:tc>
+              </a:tr>
+              <a:tr h="868680">
+                <a:tc>
+                  <a:txBody>
+                    <a:bodyPr/>
+                    <a:lstStyle/>
+                    <a:p>
+                      <a:pPr algn="ctr" indent="0" marL="0">
+                        <a:buNone/>
+                      </a:pPr>
+                      <a:r>
+                        <a:rPr lang="en-US" sz="1100" b="1" dirty="0">
+                          <a:solidFill>
+                            <a:srgbClr val="000000"/>
+                          </a:solidFill>
+                          <a:latin typeface="Verdana" pitchFamily="34" charset="0"/>
+                          <a:ea typeface="Verdana" pitchFamily="34" charset="-122"/>
+                          <a:cs typeface="Verdana" pitchFamily="34" charset="-120"/>
+                        </a:rPr>
+                        <a:t>No elegido</a:t>
+                      </a:r>
+                      <a:endParaRPr lang="en-US" sz="1100" dirty="0">
+                        <a:latin typeface="Verdana" charset="0"/>
+                        <a:ea typeface="Verdana" charset="0"/>
+                        <a:cs typeface="Verdana" charset="0"/>
+                      </a:endParaRPr>
+                    </a:p>
+                  </a:txBody>
+                  <a:tcPr marL="91440" marR="91440" marT="45720" marB="45720" anchor="ctr">
+                    <a:lnL w="9525" cap="flat" cmpd="sng" algn="ctr">
+                      <a:solidFill>
+                        <a:srgbClr val="D0D0D0"/>
+                      </a:solidFill>
+                      <a:prstDash val="solid"/>
+                      <a:round/>
+                      <a:headEnd type="none" w="med" len="med"/>
+                      <a:tailEnd type="none" w="med" len="med"/>
+                    </a:lnL>
+                    <a:lnR w="9525" cap="flat" cmpd="sng" algn="ctr">
+                      <a:solidFill>
+                        <a:srgbClr val="D0D0D0"/>
+                      </a:solidFill>
+                      <a:prstDash val="solid"/>
+                      <a:round/>
+                      <a:headEnd type="none" w="med" len="med"/>
+                      <a:tailEnd type="none" w="med" len="med"/>
+                    </a:lnR>
+                    <a:lnT w="9525" cap="flat" cmpd="sng" algn="ctr">
+                      <a:solidFill>
+                        <a:srgbClr val="D0D0D0"/>
+                      </a:solidFill>
+                      <a:prstDash val="solid"/>
+                      <a:round/>
+                      <a:headEnd type="none" w="med" len="med"/>
+                      <a:tailEnd type="none" w="med" len="med"/>
+                    </a:lnT>
+                    <a:lnB w="9525" cap="flat" cmpd="sng" algn="ctr">
+                      <a:solidFill>
+                        <a:srgbClr val="D0D0D0"/>
+                      </a:solidFill>
+                      <a:prstDash val="solid"/>
+                      <a:round/>
+                      <a:headEnd type="none" w="med" len="med"/>
+                      <a:tailEnd type="none" w="med" len="med"/>
+                    </a:lnB>
+                    <a:solidFill>
+                      <a:srgbClr val="F2F2F2"/>
+                    </a:solidFill>
+                  </a:tcPr>
+                </a:tc>
+                <a:tc>
+                  <a:txBody>
+                    <a:bodyPr/>
+                    <a:lstStyle/>
+                    <a:p>
+                      <a:pPr algn="ctr" indent="0" marL="0">
+                        <a:buNone/>
+                      </a:pPr>
+                      <a:r>
+                        <a:rPr lang="en-US" sz="1800" b="1" dirty="0">
+                          <a:solidFill>
+                            <a:srgbClr val="000000"/>
+                          </a:solidFill>
+                          <a:latin typeface="Verdana" pitchFamily="34" charset="0"/>
+                          <a:ea typeface="Verdana" pitchFamily="34" charset="-122"/>
+                          <a:cs typeface="Verdana" pitchFamily="34" charset="-120"/>
+                        </a:rPr>
+                        <a:t>4 039</a:t>
+                      </a:r>
+                      <a:endParaRPr lang="en-US" sz="1800" dirty="0">
+                        <a:latin typeface="Verdana" charset="0"/>
+                        <a:ea typeface="Verdana" charset="0"/>
+                        <a:cs typeface="Verdana" charset="0"/>
+                      </a:endParaRPr>
+                    </a:p>
+                  </a:txBody>
+                  <a:tcPr marL="91440" marR="91440" marT="45720" marB="45720" anchor="ctr">
+                    <a:lnL w="9525" cap="flat" cmpd="sng" algn="ctr">
+                      <a:solidFill>
+                        <a:srgbClr val="D0D0D0"/>
+                      </a:solidFill>
+                      <a:prstDash val="solid"/>
+                      <a:round/>
+                      <a:headEnd type="none" w="med" len="med"/>
+                      <a:tailEnd type="none" w="med" len="med"/>
+                    </a:lnL>
+                    <a:lnR w="9525" cap="flat" cmpd="sng" algn="ctr">
+                      <a:solidFill>
+                        <a:srgbClr val="D0D0D0"/>
+                      </a:solidFill>
+                      <a:prstDash val="solid"/>
+                      <a:round/>
+                      <a:headEnd type="none" w="med" len="med"/>
+                      <a:tailEnd type="none" w="med" len="med"/>
+                    </a:lnR>
+                    <a:lnT w="9525" cap="flat" cmpd="sng" algn="ctr">
+                      <a:solidFill>
+                        <a:srgbClr val="D0D0D0"/>
+                      </a:solidFill>
+                      <a:prstDash val="solid"/>
+                      <a:round/>
+                      <a:headEnd type="none" w="med" len="med"/>
+                      <a:tailEnd type="none" w="med" len="med"/>
+                    </a:lnT>
+                    <a:lnB w="9525" cap="flat" cmpd="sng" algn="ctr">
+                      <a:solidFill>
+                        <a:srgbClr val="D0D0D0"/>
+                      </a:solidFill>
+                      <a:prstDash val="solid"/>
+                      <a:round/>
+                      <a:headEnd type="none" w="med" len="med"/>
+                      <a:tailEnd type="none" w="med" len="med"/>
+                    </a:lnB>
+                    <a:solidFill>
+                      <a:srgbClr val="FFFFFF"/>
+                    </a:solidFill>
+                  </a:tcPr>
+                </a:tc>
+                <a:tc>
+                  <a:txBody>
+                    <a:bodyPr/>
+                    <a:lstStyle/>
+                    <a:p>
+                      <a:pPr algn="ctr" indent="0" marL="0">
+                        <a:buNone/>
+                      </a:pPr>
+                      <a:r>
+                        <a:rPr lang="en-US" sz="1800" b="1" dirty="0">
+                          <a:solidFill>
+                            <a:srgbClr val="000000"/>
+                          </a:solidFill>
+                          <a:latin typeface="Verdana" pitchFamily="34" charset="0"/>
+                          <a:ea typeface="Verdana" pitchFamily="34" charset="-122"/>
+                          <a:cs typeface="Verdana" pitchFamily="34" charset="-120"/>
+                        </a:rPr>
+                        <a:t>48 876</a:t>
+                      </a:r>
+                      <a:endParaRPr lang="en-US" sz="1800" dirty="0">
+                        <a:latin typeface="Verdana" charset="0"/>
+                        <a:ea typeface="Verdana" charset="0"/>
+                        <a:cs typeface="Verdana" charset="0"/>
+                      </a:endParaRPr>
+                    </a:p>
+                  </a:txBody>
+                  <a:tcPr marL="91440" marR="91440" marT="45720" marB="45720" anchor="ctr">
+                    <a:lnL w="9525" cap="flat" cmpd="sng" algn="ctr">
+                      <a:solidFill>
+                        <a:srgbClr val="D0D0D0"/>
+                      </a:solidFill>
+                      <a:prstDash val="solid"/>
+                      <a:round/>
+                      <a:headEnd type="none" w="med" len="med"/>
+                      <a:tailEnd type="none" w="med" len="med"/>
+                    </a:lnL>
+                    <a:lnR w="9525" cap="flat" cmpd="sng" algn="ctr">
+                      <a:solidFill>
+                        <a:srgbClr val="D0D0D0"/>
+                      </a:solidFill>
+                      <a:prstDash val="solid"/>
+                      <a:round/>
+                      <a:headEnd type="none" w="med" len="med"/>
+                      <a:tailEnd type="none" w="med" len="med"/>
+                    </a:lnR>
+                    <a:lnT w="9525" cap="flat" cmpd="sng" algn="ctr">
+                      <a:solidFill>
+                        <a:srgbClr val="D0D0D0"/>
+                      </a:solidFill>
+                      <a:prstDash val="solid"/>
+                      <a:round/>
+                      <a:headEnd type="none" w="med" len="med"/>
+                      <a:tailEnd type="none" w="med" len="med"/>
+                    </a:lnT>
+                    <a:lnB w="9525" cap="flat" cmpd="sng" algn="ctr">
+                      <a:solidFill>
+                        <a:srgbClr val="D0D0D0"/>
+                      </a:solidFill>
+                      <a:prstDash val="solid"/>
+                      <a:round/>
+                      <a:headEnd type="none" w="med" len="med"/>
+                      <a:tailEnd type="none" w="med" len="med"/>
+                    </a:lnB>
+                    <a:solidFill>
+                      <a:srgbClr val="FFFFFF"/>
+                    </a:solidFill>
+                  </a:tcPr>
+                </a:tc>
+              </a:tr>
+            </a:tbl>
+          </a:graphicData>
+        </a:graphic>
+      </p:graphicFrame>
+      <p:sp>
+        <p:nvSpPr>
+          <p:cNvPr id="10" name="Text 6"/>
+          <p:cNvSpPr txBox="1"/>
+          <p:nvPr/>
+        </p:nvSpPr>
+        <p:spPr>
+          <a:xfrm>
+            <a:off x="457200" y="3794760"/>
+            <a:ext cx="4846320" cy="457200"/>
+          </a:xfrm>
+          <a:prstGeom prst="rect">
+            <a:avLst/>
+          </a:prstGeom>
+          <a:noFill/>
+          <a:ln/>
+        </p:spPr>
+        <p:txBody>
+          <a:bodyPr wrap="square" lIns="0" tIns="0" rIns="0" bIns="0" rtlCol="0" anchor="t"/>
+          <a:lstStyle/>
+          <a:p>
+            <a:pPr indent="0" marL="0">
+              <a:buNone/>
+            </a:pPr>
+            <a:r>
+              <a:rPr lang="en-US" sz="1000" dirty="0">
+                <a:solidFill>
+                  <a:srgbClr val="595959"/>
+                </a:solidFill>
+                <a:latin typeface="Verdana" pitchFamily="34" charset="0"/>
+                <a:ea typeface="Verdana" pitchFamily="34" charset="-122"/>
+                <a:cs typeface="Verdana" pitchFamily="34" charset="-120"/>
+              </a:rPr>
+              <a:t>Realidad según la curva de YouTube; predicción del sistema. Por ventana de 1/100 del video.</a:t>
+            </a:r>
+            <a:endParaRPr lang="en-US" sz="1000" dirty="0"/>
+          </a:p>
+        </p:txBody>
+      </p:sp>
+      <p:sp>
+        <p:nvSpPr>
+          <p:cNvPr id="11" name="Shape 7"/>
+          <p:cNvSpPr/>
+          <p:nvPr/>
+        </p:nvSpPr>
+        <p:spPr>
+          <a:xfrm>
+            <a:off x="5577840" y="1463040"/>
+            <a:ext cx="3017520" cy="914400"/>
+          </a:xfrm>
+          <a:prstGeom prst="roundRect">
+            <a:avLst>
+              <a:gd name="adj" fmla="val 8000"/>
+            </a:avLst>
+          </a:prstGeom>
+          <a:solidFill>
+            <a:srgbClr val="F2F2F2"/>
+          </a:solidFill>
+          <a:ln w="9525">
+            <a:solidFill>
+              <a:srgbClr val="F2F2F2"/>
+            </a:solidFill>
+            <a:prstDash val="solid"/>
+          </a:ln>
+        </p:spPr>
+      </p:sp>
+      <p:sp>
+        <p:nvSpPr>
+          <p:cNvPr id="12" name="Text 8"/>
+          <p:cNvSpPr txBox="1"/>
+          <p:nvPr/>
+        </p:nvSpPr>
+        <p:spPr>
+          <a:xfrm>
+            <a:off x="5687568" y="1536192"/>
+            <a:ext cx="2798064" cy="292608"/>
+          </a:xfrm>
+          <a:prstGeom prst="rect">
+            <a:avLst/>
+          </a:prstGeom>
+          <a:noFill/>
+          <a:ln/>
+        </p:spPr>
+        <p:txBody>
+          <a:bodyPr wrap="square" lIns="0" tIns="0" rIns="0" bIns="0" rtlCol="0" anchor="ctr"/>
+          <a:lstStyle/>
+          <a:p>
+            <a:pPr indent="0" marL="0">
+              <a:buNone/>
+            </a:pPr>
+            <a:r>
+              <a:rPr lang="en-US" sz="1300" b="1" dirty="0">
+                <a:solidFill>
+                  <a:srgbClr val="FF4713"/>
+                </a:solidFill>
+                <a:latin typeface="Verdana" pitchFamily="34" charset="0"/>
+                <a:ea typeface="Verdana" pitchFamily="34" charset="-122"/>
+                <a:cs typeface="Verdana" pitchFamily="34" charset="-120"/>
+              </a:rPr>
+              <a:t>Precisión 16.8 %</a:t>
+            </a:r>
+            <a:endParaRPr lang="en-US" sz="1300" dirty="0"/>
+          </a:p>
+        </p:txBody>
+      </p:sp>
+      <p:sp>
+        <p:nvSpPr>
+          <p:cNvPr id="13" name="Text 9"/>
+          <p:cNvSpPr txBox="1"/>
+          <p:nvPr/>
+        </p:nvSpPr>
+        <p:spPr>
+          <a:xfrm>
+            <a:off x="5687568" y="1847088"/>
+            <a:ext cx="2798064" cy="457200"/>
+          </a:xfrm>
+          <a:prstGeom prst="rect">
+            <a:avLst/>
+          </a:prstGeom>
+          <a:noFill/>
+          <a:ln/>
+        </p:spPr>
+        <p:txBody>
+          <a:bodyPr wrap="square" lIns="0" tIns="0" rIns="0" bIns="0" rtlCol="0" anchor="t"/>
+          <a:lstStyle/>
+          <a:p>
+            <a:pPr indent="0" marL="0">
+              <a:buNone/>
+            </a:pPr>
+            <a:r>
+              <a:rPr lang="en-US" sz="1100" dirty="0">
+                <a:solidFill>
+                  <a:srgbClr val="595959"/>
+                </a:solidFill>
+                <a:latin typeface="Verdana" pitchFamily="34" charset="0"/>
+                <a:ea typeface="Verdana" pitchFamily="34" charset="-122"/>
+                <a:cs typeface="Verdana" pitchFamily="34" charset="-120"/>
+              </a:rPr>
+              <a:t>Azar: 8.1 %. Duplica al azar.</a:t>
+            </a:r>
+            <a:endParaRPr lang="en-US" sz="1100" dirty="0"/>
+          </a:p>
+        </p:txBody>
+      </p:sp>
+      <p:sp>
+        <p:nvSpPr>
+          <p:cNvPr id="14" name="Shape 10"/>
+          <p:cNvSpPr/>
+          <p:nvPr/>
+        </p:nvSpPr>
+        <p:spPr>
+          <a:xfrm>
+            <a:off x="5577840" y="2514600"/>
+            <a:ext cx="3017520" cy="914400"/>
+          </a:xfrm>
+          <a:prstGeom prst="roundRect">
+            <a:avLst>
+              <a:gd name="adj" fmla="val 8000"/>
+            </a:avLst>
+          </a:prstGeom>
+          <a:solidFill>
+            <a:srgbClr val="F2F2F2"/>
+          </a:solidFill>
+          <a:ln w="9525">
+            <a:solidFill>
+              <a:srgbClr val="F2F2F2"/>
+            </a:solidFill>
+            <a:prstDash val="solid"/>
+          </a:ln>
+        </p:spPr>
+      </p:sp>
+      <p:sp>
+        <p:nvSpPr>
+          <p:cNvPr id="15" name="Text 11"/>
+          <p:cNvSpPr txBox="1"/>
+          <p:nvPr/>
+        </p:nvSpPr>
+        <p:spPr>
+          <a:xfrm>
+            <a:off x="5687568" y="2587752"/>
+            <a:ext cx="2798064" cy="292608"/>
+          </a:xfrm>
+          <a:prstGeom prst="rect">
+            <a:avLst/>
+          </a:prstGeom>
+          <a:noFill/>
+          <a:ln/>
+        </p:spPr>
+        <p:txBody>
+          <a:bodyPr wrap="square" lIns="0" tIns="0" rIns="0" bIns="0" rtlCol="0" anchor="ctr"/>
+          <a:lstStyle/>
+          <a:p>
+            <a:pPr indent="0" marL="0">
+              <a:buNone/>
+            </a:pPr>
+            <a:r>
+              <a:rPr lang="en-US" sz="1300" b="1" dirty="0">
+                <a:solidFill>
+                  <a:srgbClr val="000000"/>
+                </a:solidFill>
+                <a:latin typeface="Verdana" pitchFamily="34" charset="0"/>
+                <a:ea typeface="Verdana" pitchFamily="34" charset="-122"/>
+                <a:cs typeface="Verdana" pitchFamily="34" charset="-120"/>
+              </a:rPr>
+              <a:t>Cobertura 10.4 %</a:t>
+            </a:r>
+            <a:endParaRPr lang="en-US" sz="1300" dirty="0"/>
+          </a:p>
+        </p:txBody>
+      </p:sp>
+      <p:sp>
+        <p:nvSpPr>
+          <p:cNvPr id="16" name="Text 12"/>
+          <p:cNvSpPr txBox="1"/>
+          <p:nvPr/>
+        </p:nvSpPr>
+        <p:spPr>
+          <a:xfrm>
+            <a:off x="5687568" y="2898648"/>
+            <a:ext cx="2798064" cy="457200"/>
+          </a:xfrm>
+          <a:prstGeom prst="rect">
+            <a:avLst/>
+          </a:prstGeom>
+          <a:noFill/>
+          <a:ln/>
+        </p:spPr>
+        <p:txBody>
+          <a:bodyPr wrap="square" lIns="0" tIns="0" rIns="0" bIns="0" rtlCol="0" anchor="t"/>
+          <a:lstStyle/>
+          <a:p>
+            <a:pPr indent="0" marL="0">
+              <a:buNone/>
+            </a:pPr>
+            <a:r>
+              <a:rPr lang="en-US" sz="1100" dirty="0">
+                <a:solidFill>
+                  <a:srgbClr val="595959"/>
+                </a:solidFill>
+                <a:latin typeface="Verdana" pitchFamily="34" charset="0"/>
+                <a:ea typeface="Verdana" pitchFamily="34" charset="-122"/>
+                <a:cs typeface="Verdana" pitchFamily="34" charset="-120"/>
+              </a:rPr>
+              <a:t>Solo se eligen 5 ventanas; hay muchos picos.</a:t>
+            </a:r>
+            <a:endParaRPr lang="en-US" sz="1100" dirty="0"/>
+          </a:p>
+        </p:txBody>
+      </p:sp>
+      <p:sp>
+        <p:nvSpPr>
+          <p:cNvPr id="17" name="Shape 13"/>
+          <p:cNvSpPr/>
+          <p:nvPr/>
+        </p:nvSpPr>
+        <p:spPr>
+          <a:xfrm>
+            <a:off x="5577840" y="3566160"/>
+            <a:ext cx="3017520" cy="914400"/>
+          </a:xfrm>
+          <a:prstGeom prst="roundRect">
+            <a:avLst>
+              <a:gd name="adj" fmla="val 8000"/>
+            </a:avLst>
+          </a:prstGeom>
+          <a:solidFill>
+            <a:srgbClr val="FFFFFF"/>
+          </a:solidFill>
+          <a:ln w="9525">
+            <a:solidFill>
+              <a:srgbClr val="FF4713"/>
+            </a:solidFill>
+            <a:prstDash val="solid"/>
+          </a:ln>
+        </p:spPr>
+      </p:sp>
+      <p:sp>
+        <p:nvSpPr>
+          <p:cNvPr id="18" name="Text 14"/>
+          <p:cNvSpPr txBox="1"/>
+          <p:nvPr/>
+        </p:nvSpPr>
+        <p:spPr>
+          <a:xfrm>
+            <a:off x="5687568" y="3639312"/>
+            <a:ext cx="2798064" cy="292608"/>
+          </a:xfrm>
+          <a:prstGeom prst="rect">
+            <a:avLst/>
+          </a:prstGeom>
+          <a:noFill/>
+          <a:ln/>
+        </p:spPr>
+        <p:txBody>
+          <a:bodyPr wrap="square" lIns="0" tIns="0" rIns="0" bIns="0" rtlCol="0" anchor="ctr"/>
+          <a:lstStyle/>
+          <a:p>
+            <a:pPr indent="0" marL="0">
+              <a:buNone/>
+            </a:pPr>
+            <a:r>
+              <a:rPr lang="en-US" sz="1300" b="1" dirty="0">
+                <a:solidFill>
+                  <a:srgbClr val="FF4713"/>
+                </a:solidFill>
+                <a:latin typeface="Verdana" pitchFamily="34" charset="0"/>
+                <a:ea typeface="Verdana" pitchFamily="34" charset="-122"/>
+                <a:cs typeface="Verdana" pitchFamily="34" charset="-120"/>
+              </a:rPr>
+              <a:t>Por video 55.7 %</a:t>
+            </a:r>
+            <a:endParaRPr lang="en-US" sz="1300" dirty="0"/>
+          </a:p>
+        </p:txBody>
+      </p:sp>
+      <p:sp>
+        <p:nvSpPr>
+          <p:cNvPr id="19" name="Text 15"/>
+          <p:cNvSpPr txBox="1"/>
+          <p:nvPr/>
+        </p:nvSpPr>
+        <p:spPr>
+          <a:xfrm>
+            <a:off x="5687568" y="3950208"/>
+            <a:ext cx="2798064" cy="457200"/>
+          </a:xfrm>
+          <a:prstGeom prst="rect">
+            <a:avLst/>
+          </a:prstGeom>
+          <a:noFill/>
+          <a:ln/>
+        </p:spPr>
+        <p:txBody>
+          <a:bodyPr wrap="square" lIns="0" tIns="0" rIns="0" bIns="0" rtlCol="0" anchor="t"/>
+          <a:lstStyle/>
+          <a:p>
+            <a:pPr indent="0" marL="0">
+              <a:buNone/>
+            </a:pPr>
+            <a:r>
+              <a:rPr lang="en-US" sz="1100" dirty="0">
+                <a:solidFill>
+                  <a:srgbClr val="595959"/>
+                </a:solidFill>
+                <a:latin typeface="Verdana" pitchFamily="34" charset="0"/>
+                <a:ea typeface="Verdana" pitchFamily="34" charset="-122"/>
+                <a:cs typeface="Verdana" pitchFamily="34" charset="-120"/>
+              </a:rPr>
+              <a:t>Al menos un clip sobre un pico (310 de 557).</a:t>
+            </a:r>
+            <a:endParaRPr lang="en-US" sz="1100" dirty="0"/>
+          </a:p>
+        </p:txBody>
+      </p:sp>
+    </p:spTree>
+  </p:cSld>
+  <p:clrMapOvr>
+    <a:masterClrMapping/>
+  </p:clrMapOvr>
+</p:sld>
+</file>
+
+<file path=ppt/slides/slide12.xml><?xml version="1.0" encoding="utf-8"?>
+<p:sld xmlns:a="http://schemas.openxmlformats.org/drawingml/2006/main" xmlns:r="http://schemas.openxmlformats.org/officeDocument/2006/relationships" xmlns:p="http://schemas.openxmlformats.org/presentationml/2006/main">
+  <p:cSld name="Slide 12">
+    <p:bg>
+      <p:bgPr>
+        <a:solidFill>
+          <a:srgbClr val="FFFFFF"/>
+        </a:solidFill>
+      </p:bgPr>
+    </p:bg>
+    <p:spTree>
+      <p:nvGrpSpPr>
+        <p:cNvPr id="1" name=""/>
+        <p:cNvGrpSpPr/>
+        <p:nvPr/>
+      </p:nvGrpSpPr>
+      <p:grpSpPr>
+        <a:xfrm>
+          <a:off x="0" y="0"/>
+          <a:ext cx="0" cy="0"/>
+          <a:chOff x="0" y="0"/>
+          <a:chExt cx="0" cy="0"/>
+        </a:xfrm>
+      </p:grpSpPr>
+      <p:sp>
+        <p:nvSpPr>
+          <p:cNvPr id="2" name="Shape 0"/>
+          <p:cNvSpPr/>
+          <p:nvPr/>
+        </p:nvSpPr>
+        <p:spPr>
+          <a:xfrm>
+            <a:off x="8412480" y="256032"/>
+            <a:ext cx="274320" cy="274320"/>
+          </a:xfrm>
+          <a:prstGeom prst="star5">
+            <a:avLst/>
+          </a:prstGeom>
+          <a:solidFill>
+            <a:srgbClr val="FF4713"/>
+          </a:solidFill>
+          <a:ln w="12700">
+            <a:solidFill>
+              <a:srgbClr val="FF4713"/>
+            </a:solidFill>
+            <a:prstDash val="solid"/>
+          </a:ln>
+        </p:spPr>
+      </p:sp>
+      <p:sp>
+        <p:nvSpPr>
+          <p:cNvPr id="3" name="Text 1"/>
+          <p:cNvSpPr txBox="1"/>
+          <p:nvPr/>
+        </p:nvSpPr>
+        <p:spPr>
+          <a:xfrm>
+            <a:off x="457200" y="228600"/>
+            <a:ext cx="7315200" cy="274320"/>
+          </a:xfrm>
+          <a:prstGeom prst="rect">
+            <a:avLst/>
+          </a:prstGeom>
+          <a:noFill/>
+          <a:ln/>
+        </p:spPr>
+        <p:txBody>
+          <a:bodyPr wrap="square" lIns="0" tIns="0" rIns="0" bIns="0" rtlCol="0" anchor="ctr"/>
+          <a:lstStyle/>
+          <a:p>
+            <a:pPr indent="0" marL="0">
+              <a:buNone/>
+            </a:pPr>
+            <a:r>
+              <a:rPr lang="en-US" sz="1100" b="1" dirty="0">
+                <a:solidFill>
+                  <a:srgbClr val="FF4713"/>
+                </a:solidFill>
+                <a:latin typeface="Verdana" pitchFamily="34" charset="0"/>
+                <a:ea typeface="Verdana" pitchFamily="34" charset="-122"/>
+                <a:cs typeface="Verdana" pitchFamily="34" charset="-120"/>
+              </a:rPr>
+              <a:t>5 · RESULTADOS</a:t>
+            </a:r>
+            <a:endParaRPr lang="en-US" sz="1100" dirty="0"/>
+          </a:p>
+        </p:txBody>
+      </p:sp>
+      <p:sp>
+        <p:nvSpPr>
+          <p:cNvPr id="4" name="Text 2"/>
+          <p:cNvSpPr txBox="1"/>
+          <p:nvPr/>
+        </p:nvSpPr>
+        <p:spPr>
+          <a:xfrm>
+            <a:off x="457200" y="548640"/>
+            <a:ext cx="8046720" cy="548640"/>
+          </a:xfrm>
+          <a:prstGeom prst="rect">
+            <a:avLst/>
+          </a:prstGeom>
+          <a:noFill/>
+          <a:ln/>
+        </p:spPr>
+        <p:txBody>
+          <a:bodyPr wrap="square" lIns="0" tIns="0" rIns="0" bIns="0" rtlCol="0" anchor="ctr"/>
+          <a:lstStyle/>
+          <a:p>
+            <a:pPr indent="0" marL="0">
+              <a:buNone/>
+            </a:pPr>
+            <a:r>
+              <a:rPr lang="en-US" sz="2200" b="1" dirty="0">
+                <a:solidFill>
+                  <a:srgbClr val="000000"/>
+                </a:solidFill>
+                <a:latin typeface="Verdana" pitchFamily="34" charset="0"/>
+                <a:ea typeface="Verdana" pitchFamily="34" charset="-122"/>
+                <a:cs typeface="Verdana" pitchFamily="34" charset="-120"/>
+              </a:rPr>
+              <a:t>Cómo pasamos de azar a más de 60 %</a:t>
+            </a:r>
+            <a:endParaRPr lang="en-US" sz="2200" dirty="0"/>
+          </a:p>
+        </p:txBody>
+      </p:sp>
+      <p:sp>
+        <p:nvSpPr>
+          <p:cNvPr id="5" name="Shape 3"/>
+          <p:cNvSpPr/>
+          <p:nvPr/>
+        </p:nvSpPr>
+        <p:spPr>
+          <a:xfrm>
+            <a:off x="457200" y="1143000"/>
+            <a:ext cx="731520" cy="36576"/>
+          </a:xfrm>
+          <a:prstGeom prst="rect">
+            <a:avLst/>
+          </a:prstGeom>
+          <a:solidFill>
+            <a:srgbClr val="FF4713"/>
+          </a:solidFill>
+          <a:ln w="12700">
+            <a:solidFill>
+              <a:srgbClr val="FF4713"/>
+            </a:solidFill>
+            <a:prstDash val="solid"/>
+          </a:ln>
+        </p:spPr>
+      </p:sp>
+      <p:sp>
+        <p:nvSpPr>
+          <p:cNvPr id="6" name="Text 4"/>
+          <p:cNvSpPr txBox="1"/>
+          <p:nvPr/>
+        </p:nvSpPr>
+        <p:spPr>
+          <a:xfrm>
+            <a:off x="457200" y="4800600"/>
+            <a:ext cx="5486400" cy="228600"/>
+          </a:xfrm>
+          <a:prstGeom prst="rect">
+            <a:avLst/>
+          </a:prstGeom>
+          <a:noFill/>
+          <a:ln/>
+        </p:spPr>
+        <p:txBody>
+          <a:bodyPr wrap="square" lIns="0" tIns="0" rIns="0" bIns="0" rtlCol="0" anchor="ctr"/>
+          <a:lstStyle/>
+          <a:p>
+            <a:pPr indent="0" marL="0">
+              <a:buNone/>
+            </a:pPr>
+            <a:r>
+              <a:rPr lang="en-US" sz="1000" dirty="0">
+                <a:solidFill>
+                  <a:srgbClr val="595959"/>
+                </a:solidFill>
+                <a:latin typeface="Verdana" pitchFamily="34" charset="0"/>
+                <a:ea typeface="Verdana" pitchFamily="34" charset="-122"/>
+                <a:cs typeface="Verdana" pitchFamily="34" charset="-120"/>
+              </a:rPr>
+              <a:t>Seminario de Investigación I · 2026-2</a:t>
+            </a:r>
+            <a:endParaRPr lang="en-US" sz="1000" dirty="0"/>
+          </a:p>
+        </p:txBody>
+      </p:sp>
+      <p:sp>
+        <p:nvSpPr>
+          <p:cNvPr id="7" name="Text 5"/>
+          <p:cNvSpPr txBox="1"/>
+          <p:nvPr/>
+        </p:nvSpPr>
+        <p:spPr>
+          <a:xfrm>
+            <a:off x="8229600" y="4800600"/>
+            <a:ext cx="457200" cy="228600"/>
+          </a:xfrm>
+          <a:prstGeom prst="rect">
+            <a:avLst/>
+          </a:prstGeom>
+          <a:noFill/>
+          <a:ln/>
+        </p:spPr>
+        <p:txBody>
+          <a:bodyPr wrap="square" lIns="0" tIns="0" rIns="0" bIns="0" rtlCol="0" anchor="ctr"/>
+          <a:lstStyle/>
+          <a:p>
+            <a:pPr algn="r" indent="0" marL="0">
+              <a:buNone/>
+            </a:pPr>
+            <a:r>
+              <a:rPr lang="en-US" sz="1000" dirty="0">
+                <a:solidFill>
+                  <a:srgbClr val="595959"/>
+                </a:solidFill>
+                <a:latin typeface="Verdana" pitchFamily="34" charset="0"/>
+                <a:ea typeface="Verdana" pitchFamily="34" charset="-122"/>
+                <a:cs typeface="Verdana" pitchFamily="34" charset="-120"/>
+              </a:rPr>
+              <a:t>12</a:t>
+            </a:r>
+            <a:endParaRPr lang="en-US" sz="1000" dirty="0"/>
+          </a:p>
+        </p:txBody>
+      </p:sp>
+      <p:graphicFrame>
+        <p:nvGraphicFramePr>
+          <p:cNvPr id="13" name="Table 0"/>
           <p:cNvGraphicFramePr>
             <a:graphicFrameLocks noGrp="1"/>
           </p:cNvGraphicFramePr>
@@ -6315,9 +7634,9 @@
 </p:sld>
 </file>
 
-<file path=ppt/slides/slide12.xml><?xml version="1.0" encoding="utf-8"?>
+<file path=ppt/slides/slide13.xml><?xml version="1.0" encoding="utf-8"?>
 <p:sld xmlns:a="http://schemas.openxmlformats.org/drawingml/2006/main" xmlns:r="http://schemas.openxmlformats.org/officeDocument/2006/relationships" xmlns:p="http://schemas.openxmlformats.org/presentationml/2006/main">
-  <p:cSld name="Slide 12">
+  <p:cSld name="Slide 13">
     <p:bg>
       <p:bgPr>
         <a:solidFill>
@@ -6539,7 +7858,7 @@
                 <a:ea typeface="Verdana" pitchFamily="34" charset="-122"/>
                 <a:cs typeface="Verdana" pitchFamily="34" charset="-120"/>
               </a:rPr>
-              <a:t>12</a:t>
+              <a:t>13</a:t>
             </a:r>
             <a:endParaRPr lang="en-US" sz="1000" dirty="0"/>
           </a:p>
@@ -6547,7 +7866,7 @@
       </p:sp>
       <p:graphicFrame>
         <p:nvGraphicFramePr>
-          <p:cNvPr id="13" name="Table 0"/>
+          <p:cNvPr id="14" name="Table 0"/>
           <p:cNvGraphicFramePr>
             <a:graphicFrameLocks noGrp="1"/>
           </p:cNvGraphicFramePr>
@@ -7486,702 +8805,6 @@
 </p:sld>
 </file>
 
-<file path=ppt/slides/slide13.xml><?xml version="1.0" encoding="utf-8"?>
-<p:sld xmlns:a="http://schemas.openxmlformats.org/drawingml/2006/main" xmlns:r="http://schemas.openxmlformats.org/officeDocument/2006/relationships" xmlns:p="http://schemas.openxmlformats.org/presentationml/2006/main">
-  <p:cSld name="Slide 13">
-    <p:bg>
-      <p:bgPr>
-        <a:solidFill>
-          <a:srgbClr val="FFFFFF"/>
-        </a:solidFill>
-      </p:bgPr>
-    </p:bg>
-    <p:spTree>
-      <p:nvGrpSpPr>
-        <p:cNvPr id="1" name=""/>
-        <p:cNvGrpSpPr/>
-        <p:nvPr/>
-      </p:nvGrpSpPr>
-      <p:grpSpPr>
-        <a:xfrm>
-          <a:off x="0" y="0"/>
-          <a:ext cx="0" cy="0"/>
-          <a:chOff x="0" y="0"/>
-          <a:chExt cx="0" cy="0"/>
-        </a:xfrm>
-      </p:grpSpPr>
-      <p:sp>
-        <p:nvSpPr>
-          <p:cNvPr id="2" name="Shape 0"/>
-          <p:cNvSpPr/>
-          <p:nvPr/>
-        </p:nvSpPr>
-        <p:spPr>
-          <a:xfrm>
-            <a:off x="8412480" y="256032"/>
-            <a:ext cx="274320" cy="274320"/>
-          </a:xfrm>
-          <a:prstGeom prst="star5">
-            <a:avLst/>
-          </a:prstGeom>
-          <a:solidFill>
-            <a:srgbClr val="FF4713"/>
-          </a:solidFill>
-          <a:ln w="12700">
-            <a:solidFill>
-              <a:srgbClr val="FF4713"/>
-            </a:solidFill>
-            <a:prstDash val="solid"/>
-          </a:ln>
-        </p:spPr>
-      </p:sp>
-      <p:sp>
-        <p:nvSpPr>
-          <p:cNvPr id="3" name="Text 1"/>
-          <p:cNvSpPr txBox="1"/>
-          <p:nvPr/>
-        </p:nvSpPr>
-        <p:spPr>
-          <a:xfrm>
-            <a:off x="457200" y="228600"/>
-            <a:ext cx="7315200" cy="274320"/>
-          </a:xfrm>
-          <a:prstGeom prst="rect">
-            <a:avLst/>
-          </a:prstGeom>
-          <a:noFill/>
-          <a:ln/>
-        </p:spPr>
-        <p:txBody>
-          <a:bodyPr wrap="square" lIns="0" tIns="0" rIns="0" bIns="0" rtlCol="0" anchor="ctr"/>
-          <a:lstStyle/>
-          <a:p>
-            <a:pPr indent="0" marL="0">
-              <a:buNone/>
-            </a:pPr>
-            <a:r>
-              <a:rPr lang="en-US" sz="1100" b="1" dirty="0">
-                <a:solidFill>
-                  <a:srgbClr val="FF4713"/>
-                </a:solidFill>
-                <a:latin typeface="Verdana" pitchFamily="34" charset="0"/>
-                <a:ea typeface="Verdana" pitchFamily="34" charset="-122"/>
-                <a:cs typeface="Verdana" pitchFamily="34" charset="-120"/>
-              </a:rPr>
-              <a:t>5 · RESULTADOS</a:t>
-            </a:r>
-            <a:endParaRPr lang="en-US" sz="1100" dirty="0"/>
-          </a:p>
-        </p:txBody>
-      </p:sp>
-      <p:sp>
-        <p:nvSpPr>
-          <p:cNvPr id="4" name="Text 2"/>
-          <p:cNvSpPr txBox="1"/>
-          <p:nvPr/>
-        </p:nvSpPr>
-        <p:spPr>
-          <a:xfrm>
-            <a:off x="457200" y="548640"/>
-            <a:ext cx="8046720" cy="548640"/>
-          </a:xfrm>
-          <a:prstGeom prst="rect">
-            <a:avLst/>
-          </a:prstGeom>
-          <a:noFill/>
-          <a:ln/>
-        </p:spPr>
-        <p:txBody>
-          <a:bodyPr wrap="square" lIns="0" tIns="0" rIns="0" bIns="0" rtlCol="0" anchor="ctr"/>
-          <a:lstStyle/>
-          <a:p>
-            <a:pPr indent="0" marL="0">
-              <a:buNone/>
-            </a:pPr>
-            <a:r>
-              <a:rPr lang="en-US" sz="2200" b="1" dirty="0">
-                <a:solidFill>
-                  <a:srgbClr val="000000"/>
-                </a:solidFill>
-                <a:latin typeface="Verdana" pitchFamily="34" charset="0"/>
-                <a:ea typeface="Verdana" pitchFamily="34" charset="-122"/>
-                <a:cs typeface="Verdana" pitchFamily="34" charset="-120"/>
-              </a:rPr>
-              <a:t>Ejemplo: El caso Marina y Laura (ES)</a:t>
-            </a:r>
-            <a:endParaRPr lang="en-US" sz="2200" dirty="0"/>
-          </a:p>
-        </p:txBody>
-      </p:sp>
-      <p:sp>
-        <p:nvSpPr>
-          <p:cNvPr id="5" name="Shape 3"/>
-          <p:cNvSpPr/>
-          <p:nvPr/>
-        </p:nvSpPr>
-        <p:spPr>
-          <a:xfrm>
-            <a:off x="457200" y="1143000"/>
-            <a:ext cx="731520" cy="36576"/>
-          </a:xfrm>
-          <a:prstGeom prst="rect">
-            <a:avLst/>
-          </a:prstGeom>
-          <a:solidFill>
-            <a:srgbClr val="FF4713"/>
-          </a:solidFill>
-          <a:ln w="12700">
-            <a:solidFill>
-              <a:srgbClr val="FF4713"/>
-            </a:solidFill>
-            <a:prstDash val="solid"/>
-          </a:ln>
-        </p:spPr>
-      </p:sp>
-      <p:sp>
-        <p:nvSpPr>
-          <p:cNvPr id="6" name="Text 4"/>
-          <p:cNvSpPr txBox="1"/>
-          <p:nvPr/>
-        </p:nvSpPr>
-        <p:spPr>
-          <a:xfrm>
-            <a:off x="457200" y="4800600"/>
-            <a:ext cx="5486400" cy="228600"/>
-          </a:xfrm>
-          <a:prstGeom prst="rect">
-            <a:avLst/>
-          </a:prstGeom>
-          <a:noFill/>
-          <a:ln/>
-        </p:spPr>
-        <p:txBody>
-          <a:bodyPr wrap="square" lIns="0" tIns="0" rIns="0" bIns="0" rtlCol="0" anchor="ctr"/>
-          <a:lstStyle/>
-          <a:p>
-            <a:pPr indent="0" marL="0">
-              <a:buNone/>
-            </a:pPr>
-            <a:r>
-              <a:rPr lang="en-US" sz="1000" dirty="0">
-                <a:solidFill>
-                  <a:srgbClr val="595959"/>
-                </a:solidFill>
-                <a:latin typeface="Verdana" pitchFamily="34" charset="0"/>
-                <a:ea typeface="Verdana" pitchFamily="34" charset="-122"/>
-                <a:cs typeface="Verdana" pitchFamily="34" charset="-120"/>
-              </a:rPr>
-              <a:t>Seminario de Investigación I · 2026-2</a:t>
-            </a:r>
-            <a:endParaRPr lang="en-US" sz="1000" dirty="0"/>
-          </a:p>
-        </p:txBody>
-      </p:sp>
-      <p:sp>
-        <p:nvSpPr>
-          <p:cNvPr id="7" name="Text 5"/>
-          <p:cNvSpPr txBox="1"/>
-          <p:nvPr/>
-        </p:nvSpPr>
-        <p:spPr>
-          <a:xfrm>
-            <a:off x="8229600" y="4800600"/>
-            <a:ext cx="457200" cy="228600"/>
-          </a:xfrm>
-          <a:prstGeom prst="rect">
-            <a:avLst/>
-          </a:prstGeom>
-          <a:noFill/>
-          <a:ln/>
-        </p:spPr>
-        <p:txBody>
-          <a:bodyPr wrap="square" lIns="0" tIns="0" rIns="0" bIns="0" rtlCol="0" anchor="ctr"/>
-          <a:lstStyle/>
-          <a:p>
-            <a:pPr algn="r" indent="0" marL="0">
-              <a:buNone/>
-            </a:pPr>
-            <a:r>
-              <a:rPr lang="en-US" sz="1000" dirty="0">
-                <a:solidFill>
-                  <a:srgbClr val="595959"/>
-                </a:solidFill>
-                <a:latin typeface="Verdana" pitchFamily="34" charset="0"/>
-                <a:ea typeface="Verdana" pitchFamily="34" charset="-122"/>
-                <a:cs typeface="Verdana" pitchFamily="34" charset="-120"/>
-              </a:rPr>
-              <a:t>13</a:t>
-            </a:r>
-            <a:endParaRPr lang="en-US" sz="1000" dirty="0"/>
-          </a:p>
-        </p:txBody>
-      </p:sp>
-      <p:pic>
-        <p:nvPicPr>
-          <p:cNvPr id="9" name="Mapa de calor v1" descr="img/v1_heat.png">    </p:cNvPr>
-          <p:cNvPicPr>
-            <a:picLocks noChangeAspect="1"/>
-          </p:cNvPicPr>
-          <p:nvPr/>
-        </p:nvPicPr>
-        <p:blipFill>
-          <a:blip r:embed="rId1"/>
-          <a:stretch>
-            <a:fillRect/>
-          </a:stretch>
-        </p:blipFill>
-        <p:spPr>
-          <a:xfrm>
-            <a:off x="457200" y="1280160"/>
-            <a:ext cx="8138160" cy="1737360"/>
-          </a:xfrm>
-          <a:prstGeom prst="rect">
-            <a:avLst/>
-          </a:prstGeom>
-        </p:spPr>
-      </p:pic>
-      <p:pic>
-        <p:nvPicPr>
-          <p:cNvPr id="10" name="Clip 1 v1" descr="img/v1_clip1.jpg">    </p:cNvPr>
-          <p:cNvPicPr>
-            <a:picLocks noChangeAspect="1"/>
-          </p:cNvPicPr>
-          <p:nvPr/>
-        </p:nvPicPr>
-        <p:blipFill>
-          <a:blip r:embed="rId2"/>
-          <a:srcRect l="0" r="0" t="0" b="0"/>
-          <a:stretch/>
-        </p:blipFill>
-        <p:spPr>
-          <a:xfrm>
-            <a:off x="457200" y="3108960"/>
-            <a:ext cx="868680" cy="1371600"/>
-          </a:xfrm>
-          <a:prstGeom prst="rect">
-            <a:avLst/>
-          </a:prstGeom>
-        </p:spPr>
-      </p:pic>
-      <p:sp>
-        <p:nvSpPr>
-          <p:cNvPr id="11" name="Text 6"/>
-          <p:cNvSpPr txBox="1"/>
-          <p:nvPr/>
-        </p:nvSpPr>
-        <p:spPr>
-          <a:xfrm>
-            <a:off x="1399032" y="3108960"/>
-            <a:ext cx="731520" cy="1371600"/>
-          </a:xfrm>
-          <a:prstGeom prst="rect">
-            <a:avLst/>
-          </a:prstGeom>
-          <a:noFill/>
-          <a:ln/>
-        </p:spPr>
-        <p:txBody>
-          <a:bodyPr wrap="square" lIns="0" tIns="0" rIns="0" bIns="0" rtlCol="0" anchor="t"/>
-          <a:lstStyle/>
-          <a:p>
-            <a:pPr indent="0" marL="0">
-              <a:buNone/>
-            </a:pPr>
-            <a:r>
-              <a:rPr lang="en-US" sz="900" b="1" dirty="0">
-                <a:solidFill>
-                  <a:srgbClr val="000000"/>
-                </a:solidFill>
-                <a:latin typeface="Verdana" pitchFamily="34" charset="0"/>
-                <a:ea typeface="Verdana" pitchFamily="34" charset="-122"/>
-                <a:cs typeface="Verdana" pitchFamily="34" charset="-120"/>
-              </a:rPr>
-              <a:t>#1 · min 4:27</a:t>
-            </a:r>
-            <a:endParaRPr lang="en-US" sz="900" dirty="0"/>
-          </a:p>
-          <a:p>
-            <a:pPr indent="0" marL="0">
-              <a:buNone/>
-            </a:pPr>
-            <a:r>
-              <a:rPr lang="en-US" sz="900" b="1" dirty="0">
-                <a:solidFill>
-                  <a:srgbClr val="2E7D32"/>
-                </a:solidFill>
-                <a:latin typeface="Verdana" pitchFamily="34" charset="0"/>
-                <a:ea typeface="Verdana" pitchFamily="34" charset="-122"/>
-                <a:cs typeface="Verdana" pitchFamily="34" charset="-120"/>
-              </a:rPr>
-              <a:t>score 93 · sobre pico</a:t>
-            </a:r>
-            <a:endParaRPr lang="en-US" sz="900" dirty="0"/>
-          </a:p>
-        </p:txBody>
-      </p:sp>
-      <p:pic>
-        <p:nvPicPr>
-          <p:cNvPr id="12" name="Clip 2 v1" descr="img/v1_clip2.jpg">    </p:cNvPr>
-          <p:cNvPicPr>
-            <a:picLocks noChangeAspect="1"/>
-          </p:cNvPicPr>
-          <p:nvPr/>
-        </p:nvPicPr>
-        <p:blipFill>
-          <a:blip r:embed="rId3"/>
-          <a:srcRect l="0" r="0" t="0" b="0"/>
-          <a:stretch/>
-        </p:blipFill>
-        <p:spPr>
-          <a:xfrm>
-            <a:off x="2103120" y="3108960"/>
-            <a:ext cx="868680" cy="1371600"/>
-          </a:xfrm>
-          <a:prstGeom prst="rect">
-            <a:avLst/>
-          </a:prstGeom>
-        </p:spPr>
-      </p:pic>
-      <p:sp>
-        <p:nvSpPr>
-          <p:cNvPr id="13" name="Text 7"/>
-          <p:cNvSpPr txBox="1"/>
-          <p:nvPr/>
-        </p:nvSpPr>
-        <p:spPr>
-          <a:xfrm>
-            <a:off x="3044952" y="3108960"/>
-            <a:ext cx="731520" cy="1371600"/>
-          </a:xfrm>
-          <a:prstGeom prst="rect">
-            <a:avLst/>
-          </a:prstGeom>
-          <a:noFill/>
-          <a:ln/>
-        </p:spPr>
-        <p:txBody>
-          <a:bodyPr wrap="square" lIns="0" tIns="0" rIns="0" bIns="0" rtlCol="0" anchor="t"/>
-          <a:lstStyle/>
-          <a:p>
-            <a:pPr indent="0" marL="0">
-              <a:buNone/>
-            </a:pPr>
-            <a:r>
-              <a:rPr lang="en-US" sz="900" b="1" dirty="0">
-                <a:solidFill>
-                  <a:srgbClr val="000000"/>
-                </a:solidFill>
-                <a:latin typeface="Verdana" pitchFamily="34" charset="0"/>
-                <a:ea typeface="Verdana" pitchFamily="34" charset="-122"/>
-                <a:cs typeface="Verdana" pitchFamily="34" charset="-120"/>
-              </a:rPr>
-              <a:t>#2 · min 34:44</a:t>
-            </a:r>
-            <a:endParaRPr lang="en-US" sz="900" dirty="0"/>
-          </a:p>
-          <a:p>
-            <a:pPr indent="0" marL="0">
-              <a:buNone/>
-            </a:pPr>
-            <a:r>
-              <a:rPr lang="en-US" sz="900" b="1" dirty="0">
-                <a:solidFill>
-                  <a:srgbClr val="2E7D32"/>
-                </a:solidFill>
-                <a:latin typeface="Verdana" pitchFamily="34" charset="0"/>
-                <a:ea typeface="Verdana" pitchFamily="34" charset="-122"/>
-                <a:cs typeface="Verdana" pitchFamily="34" charset="-120"/>
-              </a:rPr>
-              <a:t>score 89 · sobre pico</a:t>
-            </a:r>
-            <a:endParaRPr lang="en-US" sz="900" dirty="0"/>
-          </a:p>
-        </p:txBody>
-      </p:sp>
-      <p:pic>
-        <p:nvPicPr>
-          <p:cNvPr id="14" name="Clip 3 v1" descr="img/v1_clip3.jpg">    </p:cNvPr>
-          <p:cNvPicPr>
-            <a:picLocks noChangeAspect="1"/>
-          </p:cNvPicPr>
-          <p:nvPr/>
-        </p:nvPicPr>
-        <p:blipFill>
-          <a:blip r:embed="rId4"/>
-          <a:srcRect l="0" r="0" t="0" b="0"/>
-          <a:stretch/>
-        </p:blipFill>
-        <p:spPr>
-          <a:xfrm>
-            <a:off x="3749040" y="3108960"/>
-            <a:ext cx="868680" cy="1371600"/>
-          </a:xfrm>
-          <a:prstGeom prst="rect">
-            <a:avLst/>
-          </a:prstGeom>
-        </p:spPr>
-      </p:pic>
-      <p:sp>
-        <p:nvSpPr>
-          <p:cNvPr id="15" name="Text 8"/>
-          <p:cNvSpPr txBox="1"/>
-          <p:nvPr/>
-        </p:nvSpPr>
-        <p:spPr>
-          <a:xfrm>
-            <a:off x="4690872" y="3108960"/>
-            <a:ext cx="731520" cy="1371600"/>
-          </a:xfrm>
-          <a:prstGeom prst="rect">
-            <a:avLst/>
-          </a:prstGeom>
-          <a:noFill/>
-          <a:ln/>
-        </p:spPr>
-        <p:txBody>
-          <a:bodyPr wrap="square" lIns="0" tIns="0" rIns="0" bIns="0" rtlCol="0" anchor="t"/>
-          <a:lstStyle/>
-          <a:p>
-            <a:pPr indent="0" marL="0">
-              <a:buNone/>
-            </a:pPr>
-            <a:r>
-              <a:rPr lang="en-US" sz="900" b="1" dirty="0">
-                <a:solidFill>
-                  <a:srgbClr val="000000"/>
-                </a:solidFill>
-                <a:latin typeface="Verdana" pitchFamily="34" charset="0"/>
-                <a:ea typeface="Verdana" pitchFamily="34" charset="-122"/>
-                <a:cs typeface="Verdana" pitchFamily="34" charset="-120"/>
-              </a:rPr>
-              <a:t>#3 · min 8:29</a:t>
-            </a:r>
-            <a:endParaRPr lang="en-US" sz="900" dirty="0"/>
-          </a:p>
-          <a:p>
-            <a:pPr indent="0" marL="0">
-              <a:buNone/>
-            </a:pPr>
-            <a:r>
-              <a:rPr lang="en-US" sz="900" b="1" dirty="0">
-                <a:solidFill>
-                  <a:srgbClr val="2E7D32"/>
-                </a:solidFill>
-                <a:latin typeface="Verdana" pitchFamily="34" charset="0"/>
-                <a:ea typeface="Verdana" pitchFamily="34" charset="-122"/>
-                <a:cs typeface="Verdana" pitchFamily="34" charset="-120"/>
-              </a:rPr>
-              <a:t>score 88 · sobre pico</a:t>
-            </a:r>
-            <a:endParaRPr lang="en-US" sz="900" dirty="0"/>
-          </a:p>
-        </p:txBody>
-      </p:sp>
-      <p:pic>
-        <p:nvPicPr>
-          <p:cNvPr id="16" name="Clip 4 v1" descr="img/v1_clip4.jpg">    </p:cNvPr>
-          <p:cNvPicPr>
-            <a:picLocks noChangeAspect="1"/>
-          </p:cNvPicPr>
-          <p:nvPr/>
-        </p:nvPicPr>
-        <p:blipFill>
-          <a:blip r:embed="rId5"/>
-          <a:srcRect l="0" r="0" t="0" b="0"/>
-          <a:stretch/>
-        </p:blipFill>
-        <p:spPr>
-          <a:xfrm>
-            <a:off x="5394960" y="3108960"/>
-            <a:ext cx="868680" cy="1371600"/>
-          </a:xfrm>
-          <a:prstGeom prst="rect">
-            <a:avLst/>
-          </a:prstGeom>
-        </p:spPr>
-      </p:pic>
-      <p:sp>
-        <p:nvSpPr>
-          <p:cNvPr id="17" name="Text 9"/>
-          <p:cNvSpPr txBox="1"/>
-          <p:nvPr/>
-        </p:nvSpPr>
-        <p:spPr>
-          <a:xfrm>
-            <a:off x="6336792" y="3108960"/>
-            <a:ext cx="731520" cy="1371600"/>
-          </a:xfrm>
-          <a:prstGeom prst="rect">
-            <a:avLst/>
-          </a:prstGeom>
-          <a:noFill/>
-          <a:ln/>
-        </p:spPr>
-        <p:txBody>
-          <a:bodyPr wrap="square" lIns="0" tIns="0" rIns="0" bIns="0" rtlCol="0" anchor="t"/>
-          <a:lstStyle/>
-          <a:p>
-            <a:pPr indent="0" marL="0">
-              <a:buNone/>
-            </a:pPr>
-            <a:r>
-              <a:rPr lang="en-US" sz="900" b="1" dirty="0">
-                <a:solidFill>
-                  <a:srgbClr val="000000"/>
-                </a:solidFill>
-                <a:latin typeface="Verdana" pitchFamily="34" charset="0"/>
-                <a:ea typeface="Verdana" pitchFamily="34" charset="-122"/>
-                <a:cs typeface="Verdana" pitchFamily="34" charset="-120"/>
-              </a:rPr>
-              <a:t>#4 · min 30:04</a:t>
-            </a:r>
-            <a:endParaRPr lang="en-US" sz="900" dirty="0"/>
-          </a:p>
-          <a:p>
-            <a:pPr indent="0" marL="0">
-              <a:buNone/>
-            </a:pPr>
-            <a:r>
-              <a:rPr lang="en-US" sz="900" b="1" dirty="0">
-                <a:solidFill>
-                  <a:srgbClr val="2E7D32"/>
-                </a:solidFill>
-                <a:latin typeface="Verdana" pitchFamily="34" charset="0"/>
-                <a:ea typeface="Verdana" pitchFamily="34" charset="-122"/>
-                <a:cs typeface="Verdana" pitchFamily="34" charset="-120"/>
-              </a:rPr>
-              <a:t>score 83 · sobre pico</a:t>
-            </a:r>
-            <a:endParaRPr lang="en-US" sz="900" dirty="0"/>
-          </a:p>
-        </p:txBody>
-      </p:sp>
-      <p:pic>
-        <p:nvPicPr>
-          <p:cNvPr id="18" name="Clip 5 v1" descr="img/v1_clip5.jpg">    </p:cNvPr>
-          <p:cNvPicPr>
-            <a:picLocks noChangeAspect="1"/>
-          </p:cNvPicPr>
-          <p:nvPr/>
-        </p:nvPicPr>
-        <p:blipFill>
-          <a:blip r:embed="rId6"/>
-          <a:srcRect l="0" r="0" t="0" b="0"/>
-          <a:stretch/>
-        </p:blipFill>
-        <p:spPr>
-          <a:xfrm>
-            <a:off x="7040880" y="3108960"/>
-            <a:ext cx="868680" cy="1371600"/>
-          </a:xfrm>
-          <a:prstGeom prst="rect">
-            <a:avLst/>
-          </a:prstGeom>
-        </p:spPr>
-      </p:pic>
-      <p:sp>
-        <p:nvSpPr>
-          <p:cNvPr id="19" name="Text 10"/>
-          <p:cNvSpPr txBox="1"/>
-          <p:nvPr/>
-        </p:nvSpPr>
-        <p:spPr>
-          <a:xfrm>
-            <a:off x="7982712" y="3108960"/>
-            <a:ext cx="731520" cy="1371600"/>
-          </a:xfrm>
-          <a:prstGeom prst="rect">
-            <a:avLst/>
-          </a:prstGeom>
-          <a:noFill/>
-          <a:ln/>
-        </p:spPr>
-        <p:txBody>
-          <a:bodyPr wrap="square" lIns="0" tIns="0" rIns="0" bIns="0" rtlCol="0" anchor="t"/>
-          <a:lstStyle/>
-          <a:p>
-            <a:pPr indent="0" marL="0">
-              <a:buNone/>
-            </a:pPr>
-            <a:r>
-              <a:rPr lang="en-US" sz="900" b="1" dirty="0">
-                <a:solidFill>
-                  <a:srgbClr val="000000"/>
-                </a:solidFill>
-                <a:latin typeface="Verdana" pitchFamily="34" charset="0"/>
-                <a:ea typeface="Verdana" pitchFamily="34" charset="-122"/>
-                <a:cs typeface="Verdana" pitchFamily="34" charset="-120"/>
-              </a:rPr>
-              <a:t>#5 · min 15:33</a:t>
-            </a:r>
-            <a:endParaRPr lang="en-US" sz="900" dirty="0"/>
-          </a:p>
-          <a:p>
-            <a:pPr indent="0" marL="0">
-              <a:buNone/>
-            </a:pPr>
-            <a:r>
-              <a:rPr lang="en-US" sz="900" dirty="0">
-                <a:solidFill>
-                  <a:srgbClr val="595959"/>
-                </a:solidFill>
-                <a:latin typeface="Verdana" pitchFamily="34" charset="0"/>
-                <a:ea typeface="Verdana" pitchFamily="34" charset="-122"/>
-                <a:cs typeface="Verdana" pitchFamily="34" charset="-120"/>
-              </a:rPr>
-              <a:t>score 81 · fuera</a:t>
-            </a:r>
-            <a:endParaRPr lang="en-US" sz="900" dirty="0"/>
-          </a:p>
-        </p:txBody>
-      </p:sp>
-      <p:sp>
-        <p:nvSpPr>
-          <p:cNvPr id="20" name="Text 11"/>
-          <p:cNvSpPr txBox="1"/>
-          <p:nvPr/>
-        </p:nvSpPr>
-        <p:spPr>
-          <a:xfrm>
-            <a:off x="4937760" y="1051560"/>
-            <a:ext cx="3657600" cy="228600"/>
-          </a:xfrm>
-          <a:prstGeom prst="rect">
-            <a:avLst/>
-          </a:prstGeom>
-          <a:noFill/>
-          <a:ln/>
-        </p:spPr>
-        <p:txBody>
-          <a:bodyPr wrap="square" lIns="0" tIns="0" rIns="0" bIns="0" rtlCol="0" anchor="ctr"/>
-          <a:lstStyle/>
-          <a:p>
-            <a:pPr algn="r" indent="0" marL="0">
-              <a:buNone/>
-            </a:pPr>
-            <a:r>
-              <a:rPr lang="en-US" sz="1100" b="1" dirty="0">
-                <a:solidFill>
-                  <a:srgbClr val="2E7D32"/>
-                </a:solidFill>
-                <a:latin typeface="Verdana" pitchFamily="34" charset="0"/>
-                <a:ea typeface="Verdana" pitchFamily="34" charset="-122"/>
-                <a:cs typeface="Verdana" pitchFamily="34" charset="-120"/>
-              </a:rPr>
-              <a:t>4 de 5 clips sobre un pico real</a:t>
-            </a:r>
-            <a:endParaRPr lang="en-US" sz="1100" dirty="0"/>
-          </a:p>
-        </p:txBody>
-      </p:sp>
-    </p:spTree>
-  </p:cSld>
-  <p:clrMapOvr>
-    <a:masterClrMapping/>
-  </p:clrMapOvr>
-</p:sld>
-</file>
-
 <file path=ppt/slides/slide14.xml><?xml version="1.0" encoding="utf-8"?>
 <p:sld xmlns:a="http://schemas.openxmlformats.org/drawingml/2006/main" xmlns:r="http://schemas.openxmlformats.org/officeDocument/2006/relationships" xmlns:p="http://schemas.openxmlformats.org/presentationml/2006/main">
   <p:cSld name="Slide 14">
@@ -8303,7 +8926,7 @@
                 <a:ea typeface="Verdana" pitchFamily="34" charset="-122"/>
                 <a:cs typeface="Verdana" pitchFamily="34" charset="-120"/>
               </a:rPr>
-              <a:t>Ejemplo: Dr. Anita Philips (EN)</a:t>
+              <a:t>Ejemplo: El caso Marina y Laura (ES)</a:t>
             </a:r>
             <a:endParaRPr lang="en-US" sz="2200" dirty="0"/>
           </a:p>
@@ -8414,7 +9037,7 @@
       </p:sp>
       <p:pic>
         <p:nvPicPr>
-          <p:cNvPr id="9" name="Mapa de calor v2" descr="img/v2_heat.png">    </p:cNvPr>
+          <p:cNvPr id="9" name="Mapa de calor v1" descr="img/v1_heat.png">    </p:cNvPr>
           <p:cNvPicPr>
             <a:picLocks noChangeAspect="1"/>
           </p:cNvPicPr>
@@ -8438,7 +9061,7 @@
       </p:pic>
       <p:pic>
         <p:nvPicPr>
-          <p:cNvPr id="10" name="Clip 1 v2" descr="img/v2_clip1.jpg">    </p:cNvPr>
+          <p:cNvPr id="10" name="Clip 1 v1" descr="img/v1_clip1.jpg">    </p:cNvPr>
           <p:cNvPicPr>
             <a:picLocks noChangeAspect="1"/>
           </p:cNvPicPr>
@@ -8492,7 +9115,7 @@
                 <a:ea typeface="Verdana" pitchFamily="34" charset="-122"/>
                 <a:cs typeface="Verdana" pitchFamily="34" charset="-120"/>
               </a:rPr>
-              <a:t>#1 · min 48:39</a:t>
+              <a:t>#1 · min 4:27</a:t>
             </a:r>
             <a:endParaRPr lang="en-US" sz="900" dirty="0"/>
           </a:p>
@@ -8509,7 +9132,7 @@
                 <a:ea typeface="Verdana" pitchFamily="34" charset="-122"/>
                 <a:cs typeface="Verdana" pitchFamily="34" charset="-120"/>
               </a:rPr>
-              <a:t>score 98 · sobre pico</a:t>
+              <a:t>score 93 · sobre pico</a:t>
             </a:r>
             <a:endParaRPr lang="en-US" sz="900" dirty="0"/>
           </a:p>
@@ -8517,7 +9140,7 @@
       </p:sp>
       <p:pic>
         <p:nvPicPr>
-          <p:cNvPr id="12" name="Clip 2 v2" descr="img/v2_clip2.jpg">    </p:cNvPr>
+          <p:cNvPr id="12" name="Clip 2 v1" descr="img/v1_clip2.jpg">    </p:cNvPr>
           <p:cNvPicPr>
             <a:picLocks noChangeAspect="1"/>
           </p:cNvPicPr>
@@ -8571,7 +9194,7 @@
                 <a:ea typeface="Verdana" pitchFamily="34" charset="-122"/>
                 <a:cs typeface="Verdana" pitchFamily="34" charset="-120"/>
               </a:rPr>
-              <a:t>#2 · min 46:44</a:t>
+              <a:t>#2 · min 34:44</a:t>
             </a:r>
             <a:endParaRPr lang="en-US" sz="900" dirty="0"/>
           </a:p>
@@ -8580,15 +9203,15 @@
               <a:buNone/>
             </a:pPr>
             <a:r>
-              <a:rPr lang="en-US" sz="900" dirty="0">
-                <a:solidFill>
-                  <a:srgbClr val="595959"/>
-                </a:solidFill>
-                <a:latin typeface="Verdana" pitchFamily="34" charset="0"/>
-                <a:ea typeface="Verdana" pitchFamily="34" charset="-122"/>
-                <a:cs typeface="Verdana" pitchFamily="34" charset="-120"/>
-              </a:rPr>
-              <a:t>score 96 · fuera</a:t>
+              <a:rPr lang="en-US" sz="900" b="1" dirty="0">
+                <a:solidFill>
+                  <a:srgbClr val="2E7D32"/>
+                </a:solidFill>
+                <a:latin typeface="Verdana" pitchFamily="34" charset="0"/>
+                <a:ea typeface="Verdana" pitchFamily="34" charset="-122"/>
+                <a:cs typeface="Verdana" pitchFamily="34" charset="-120"/>
+              </a:rPr>
+              <a:t>score 89 · sobre pico</a:t>
             </a:r>
             <a:endParaRPr lang="en-US" sz="900" dirty="0"/>
           </a:p>
@@ -8596,7 +9219,7 @@
       </p:sp>
       <p:pic>
         <p:nvPicPr>
-          <p:cNvPr id="14" name="Clip 3 v2" descr="img/v2_clip3.jpg">    </p:cNvPr>
+          <p:cNvPr id="14" name="Clip 3 v1" descr="img/v1_clip3.jpg">    </p:cNvPr>
           <p:cNvPicPr>
             <a:picLocks noChangeAspect="1"/>
           </p:cNvPicPr>
@@ -8650,7 +9273,7 @@
                 <a:ea typeface="Verdana" pitchFamily="34" charset="-122"/>
                 <a:cs typeface="Verdana" pitchFamily="34" charset="-120"/>
               </a:rPr>
-              <a:t>#3 · min 62:16</a:t>
+              <a:t>#3 · min 8:29</a:t>
             </a:r>
             <a:endParaRPr lang="en-US" sz="900" dirty="0"/>
           </a:p>
@@ -8667,7 +9290,7 @@
                 <a:ea typeface="Verdana" pitchFamily="34" charset="-122"/>
                 <a:cs typeface="Verdana" pitchFamily="34" charset="-120"/>
               </a:rPr>
-              <a:t>score 96 · sobre pico</a:t>
+              <a:t>score 88 · sobre pico</a:t>
             </a:r>
             <a:endParaRPr lang="en-US" sz="900" dirty="0"/>
           </a:p>
@@ -8675,7 +9298,7 @@
       </p:sp>
       <p:pic>
         <p:nvPicPr>
-          <p:cNvPr id="16" name="Clip 4 v2" descr="img/v2_clip4.jpg">    </p:cNvPr>
+          <p:cNvPr id="16" name="Clip 4 v1" descr="img/v1_clip4.jpg">    </p:cNvPr>
           <p:cNvPicPr>
             <a:picLocks noChangeAspect="1"/>
           </p:cNvPicPr>
@@ -8729,7 +9352,7 @@
                 <a:ea typeface="Verdana" pitchFamily="34" charset="-122"/>
                 <a:cs typeface="Verdana" pitchFamily="34" charset="-120"/>
               </a:rPr>
-              <a:t>#4 · min 65:13</a:t>
+              <a:t>#4 · min 30:04</a:t>
             </a:r>
             <a:endParaRPr lang="en-US" sz="900" dirty="0"/>
           </a:p>
@@ -8746,7 +9369,7 @@
                 <a:ea typeface="Verdana" pitchFamily="34" charset="-122"/>
                 <a:cs typeface="Verdana" pitchFamily="34" charset="-120"/>
               </a:rPr>
-              <a:t>score 93 · sobre pico</a:t>
+              <a:t>score 83 · sobre pico</a:t>
             </a:r>
             <a:endParaRPr lang="en-US" sz="900" dirty="0"/>
           </a:p>
@@ -8754,7 +9377,7 @@
       </p:sp>
       <p:pic>
         <p:nvPicPr>
-          <p:cNvPr id="18" name="Clip 5 v2" descr="img/v2_clip5.jpg">    </p:cNvPr>
+          <p:cNvPr id="18" name="Clip 5 v1" descr="img/v1_clip5.jpg">    </p:cNvPr>
           <p:cNvPicPr>
             <a:picLocks noChangeAspect="1"/>
           </p:cNvPicPr>
@@ -8808,7 +9431,7 @@
                 <a:ea typeface="Verdana" pitchFamily="34" charset="-122"/>
                 <a:cs typeface="Verdana" pitchFamily="34" charset="-120"/>
               </a:rPr>
-              <a:t>#5 · min 70:31</a:t>
+              <a:t>#5 · min 15:33</a:t>
             </a:r>
             <a:endParaRPr lang="en-US" sz="900" dirty="0"/>
           </a:p>
@@ -8825,7 +9448,7 @@
                 <a:ea typeface="Verdana" pitchFamily="34" charset="-122"/>
                 <a:cs typeface="Verdana" pitchFamily="34" charset="-120"/>
               </a:rPr>
-              <a:t>score 92 · fuera</a:t>
+              <a:t>score 81 · fuera</a:t>
             </a:r>
             <a:endParaRPr lang="en-US" sz="900" dirty="0"/>
           </a:p>
@@ -8864,7 +9487,7 @@
                 <a:ea typeface="Verdana" pitchFamily="34" charset="-122"/>
                 <a:cs typeface="Verdana" pitchFamily="34" charset="-120"/>
               </a:rPr>
-              <a:t>3 de 5 clips sobre un pico real</a:t>
+              <a:t>4 de 5 clips sobre un pico real</a:t>
             </a:r>
             <a:endParaRPr lang="en-US" sz="1100" dirty="0"/>
           </a:p>
@@ -8999,7 +9622,7 @@
                 <a:ea typeface="Verdana" pitchFamily="34" charset="-122"/>
                 <a:cs typeface="Verdana" pitchFamily="34" charset="-120"/>
               </a:rPr>
-              <a:t>Ejemplo: Men's Round Table (EN)</a:t>
+              <a:t>Ejemplo: Dr. Anita Philips (EN)</a:t>
             </a:r>
             <a:endParaRPr lang="en-US" sz="2200" dirty="0"/>
           </a:p>
@@ -9110,7 +9733,7 @@
       </p:sp>
       <p:pic>
         <p:nvPicPr>
-          <p:cNvPr id="9" name="Mapa de calor v3" descr="img/v3_heat.png">    </p:cNvPr>
+          <p:cNvPr id="9" name="Mapa de calor v2" descr="img/v2_heat.png">    </p:cNvPr>
           <p:cNvPicPr>
             <a:picLocks noChangeAspect="1"/>
           </p:cNvPicPr>
@@ -9134,7 +9757,7 @@
       </p:pic>
       <p:pic>
         <p:nvPicPr>
-          <p:cNvPr id="10" name="Clip 1 v3" descr="img/v3_clip1.jpg">    </p:cNvPr>
+          <p:cNvPr id="10" name="Clip 1 v2" descr="img/v2_clip1.jpg">    </p:cNvPr>
           <p:cNvPicPr>
             <a:picLocks noChangeAspect="1"/>
           </p:cNvPicPr>
@@ -9188,7 +9811,7 @@
                 <a:ea typeface="Verdana" pitchFamily="34" charset="-122"/>
                 <a:cs typeface="Verdana" pitchFamily="34" charset="-120"/>
               </a:rPr>
-              <a:t>#1 · min 16:11</a:t>
+              <a:t>#1 · min 48:39</a:t>
             </a:r>
             <a:endParaRPr lang="en-US" sz="900" dirty="0"/>
           </a:p>
@@ -9205,7 +9828,7 @@
                 <a:ea typeface="Verdana" pitchFamily="34" charset="-122"/>
                 <a:cs typeface="Verdana" pitchFamily="34" charset="-120"/>
               </a:rPr>
-              <a:t>score 85 · sobre pico</a:t>
+              <a:t>score 98 · sobre pico</a:t>
             </a:r>
             <a:endParaRPr lang="en-US" sz="900" dirty="0"/>
           </a:p>
@@ -9213,7 +9836,7 @@
       </p:sp>
       <p:pic>
         <p:nvPicPr>
-          <p:cNvPr id="12" name="Clip 2 v3" descr="img/v3_clip2.jpg">    </p:cNvPr>
+          <p:cNvPr id="12" name="Clip 2 v2" descr="img/v2_clip2.jpg">    </p:cNvPr>
           <p:cNvPicPr>
             <a:picLocks noChangeAspect="1"/>
           </p:cNvPicPr>
@@ -9267,7 +9890,7 @@
                 <a:ea typeface="Verdana" pitchFamily="34" charset="-122"/>
                 <a:cs typeface="Verdana" pitchFamily="34" charset="-120"/>
               </a:rPr>
-              <a:t>#2 · min 7:19</a:t>
+              <a:t>#2 · min 46:44</a:t>
             </a:r>
             <a:endParaRPr lang="en-US" sz="900" dirty="0"/>
           </a:p>
@@ -9276,15 +9899,15 @@
               <a:buNone/>
             </a:pPr>
             <a:r>
-              <a:rPr lang="en-US" sz="900" b="1" dirty="0">
-                <a:solidFill>
-                  <a:srgbClr val="2E7D32"/>
-                </a:solidFill>
-                <a:latin typeface="Verdana" pitchFamily="34" charset="0"/>
-                <a:ea typeface="Verdana" pitchFamily="34" charset="-122"/>
-                <a:cs typeface="Verdana" pitchFamily="34" charset="-120"/>
-              </a:rPr>
-              <a:t>score 65 · sobre pico</a:t>
+              <a:rPr lang="en-US" sz="900" dirty="0">
+                <a:solidFill>
+                  <a:srgbClr val="595959"/>
+                </a:solidFill>
+                <a:latin typeface="Verdana" pitchFamily="34" charset="0"/>
+                <a:ea typeface="Verdana" pitchFamily="34" charset="-122"/>
+                <a:cs typeface="Verdana" pitchFamily="34" charset="-120"/>
+              </a:rPr>
+              <a:t>score 96 · fuera</a:t>
             </a:r>
             <a:endParaRPr lang="en-US" sz="900" dirty="0"/>
           </a:p>
@@ -9292,7 +9915,7 @@
       </p:sp>
       <p:pic>
         <p:nvPicPr>
-          <p:cNvPr id="14" name="Clip 3 v3" descr="img/v3_clip3.jpg">    </p:cNvPr>
+          <p:cNvPr id="14" name="Clip 3 v2" descr="img/v2_clip3.jpg">    </p:cNvPr>
           <p:cNvPicPr>
             <a:picLocks noChangeAspect="1"/>
           </p:cNvPicPr>
@@ -9346,7 +9969,7 @@
                 <a:ea typeface="Verdana" pitchFamily="34" charset="-122"/>
                 <a:cs typeface="Verdana" pitchFamily="34" charset="-120"/>
               </a:rPr>
-              <a:t>#3 · min 21:08</a:t>
+              <a:t>#3 · min 62:16</a:t>
             </a:r>
             <a:endParaRPr lang="en-US" sz="900" dirty="0"/>
           </a:p>
@@ -9355,15 +9978,15 @@
               <a:buNone/>
             </a:pPr>
             <a:r>
-              <a:rPr lang="en-US" sz="900" dirty="0">
-                <a:solidFill>
-                  <a:srgbClr val="595959"/>
-                </a:solidFill>
-                <a:latin typeface="Verdana" pitchFamily="34" charset="0"/>
-                <a:ea typeface="Verdana" pitchFamily="34" charset="-122"/>
-                <a:cs typeface="Verdana" pitchFamily="34" charset="-120"/>
-              </a:rPr>
-              <a:t>score 56 · fuera</a:t>
+              <a:rPr lang="en-US" sz="900" b="1" dirty="0">
+                <a:solidFill>
+                  <a:srgbClr val="2E7D32"/>
+                </a:solidFill>
+                <a:latin typeface="Verdana" pitchFamily="34" charset="0"/>
+                <a:ea typeface="Verdana" pitchFamily="34" charset="-122"/>
+                <a:cs typeface="Verdana" pitchFamily="34" charset="-120"/>
+              </a:rPr>
+              <a:t>score 96 · sobre pico</a:t>
             </a:r>
             <a:endParaRPr lang="en-US" sz="900" dirty="0"/>
           </a:p>
@@ -9371,7 +9994,7 @@
       </p:sp>
       <p:pic>
         <p:nvPicPr>
-          <p:cNvPr id="16" name="Clip 4 v3" descr="img/v3_clip4.jpg">    </p:cNvPr>
+          <p:cNvPr id="16" name="Clip 4 v2" descr="img/v2_clip4.jpg">    </p:cNvPr>
           <p:cNvPicPr>
             <a:picLocks noChangeAspect="1"/>
           </p:cNvPicPr>
@@ -9425,7 +10048,7 @@
                 <a:ea typeface="Verdana" pitchFamily="34" charset="-122"/>
                 <a:cs typeface="Verdana" pitchFamily="34" charset="-120"/>
               </a:rPr>
-              <a:t>#4 · min 9:19</a:t>
+              <a:t>#4 · min 65:13</a:t>
             </a:r>
             <a:endParaRPr lang="en-US" sz="900" dirty="0"/>
           </a:p>
@@ -9442,7 +10065,7 @@
                 <a:ea typeface="Verdana" pitchFamily="34" charset="-122"/>
                 <a:cs typeface="Verdana" pitchFamily="34" charset="-120"/>
               </a:rPr>
-              <a:t>score 37 · sobre pico</a:t>
+              <a:t>score 93 · sobre pico</a:t>
             </a:r>
             <a:endParaRPr lang="en-US" sz="900" dirty="0"/>
           </a:p>
@@ -9450,7 +10073,7 @@
       </p:sp>
       <p:pic>
         <p:nvPicPr>
-          <p:cNvPr id="18" name="Clip 5 v3" descr="img/v3_clip5.jpg">    </p:cNvPr>
+          <p:cNvPr id="18" name="Clip 5 v2" descr="img/v2_clip5.jpg">    </p:cNvPr>
           <p:cNvPicPr>
             <a:picLocks noChangeAspect="1"/>
           </p:cNvPicPr>
@@ -9504,7 +10127,7 @@
                 <a:ea typeface="Verdana" pitchFamily="34" charset="-122"/>
                 <a:cs typeface="Verdana" pitchFamily="34" charset="-120"/>
               </a:rPr>
-              <a:t>#5 · min 20:30</a:t>
+              <a:t>#5 · min 70:31</a:t>
             </a:r>
             <a:endParaRPr lang="en-US" sz="900" dirty="0"/>
           </a:p>
@@ -9521,7 +10144,7 @@
                 <a:ea typeface="Verdana" pitchFamily="34" charset="-122"/>
                 <a:cs typeface="Verdana" pitchFamily="34" charset="-120"/>
               </a:rPr>
-              <a:t>score 34 · fuera</a:t>
+              <a:t>score 92 · fuera</a:t>
             </a:r>
             <a:endParaRPr lang="en-US" sz="900" dirty="0"/>
           </a:p>
@@ -9656,7 +10279,7 @@
                 <a:ea typeface="Verdana" pitchFamily="34" charset="-122"/>
                 <a:cs typeface="Verdana" pitchFamily="34" charset="-120"/>
               </a:rPr>
-              <a:t>6 · ALCANCE Y SIGUIENTES PASOS</a:t>
+              <a:t>5 · RESULTADOS</a:t>
             </a:r>
             <a:endParaRPr lang="en-US" sz="1100" dirty="0"/>
           </a:p>
@@ -9695,7 +10318,7 @@
                 <a:ea typeface="Verdana" pitchFamily="34" charset="-122"/>
                 <a:cs typeface="Verdana" pitchFamily="34" charset="-120"/>
               </a:rPr>
-              <a:t>Qué se logró y qué falta</a:t>
+              <a:t>Ejemplo: Men's Round Table (EN)</a:t>
             </a:r>
             <a:endParaRPr lang="en-US" sz="2200" dirty="0"/>
           </a:p>
@@ -9799,6 +10422,702 @@
                 <a:cs typeface="Verdana" pitchFamily="34" charset="-120"/>
               </a:rPr>
               <a:t>16</a:t>
+            </a:r>
+            <a:endParaRPr lang="en-US" sz="1000" dirty="0"/>
+          </a:p>
+        </p:txBody>
+      </p:sp>
+      <p:pic>
+        <p:nvPicPr>
+          <p:cNvPr id="9" name="Mapa de calor v3" descr="img/v3_heat.png">    </p:cNvPr>
+          <p:cNvPicPr>
+            <a:picLocks noChangeAspect="1"/>
+          </p:cNvPicPr>
+          <p:nvPr/>
+        </p:nvPicPr>
+        <p:blipFill>
+          <a:blip r:embed="rId1"/>
+          <a:stretch>
+            <a:fillRect/>
+          </a:stretch>
+        </p:blipFill>
+        <p:spPr>
+          <a:xfrm>
+            <a:off x="457200" y="1280160"/>
+            <a:ext cx="8138160" cy="1737360"/>
+          </a:xfrm>
+          <a:prstGeom prst="rect">
+            <a:avLst/>
+          </a:prstGeom>
+        </p:spPr>
+      </p:pic>
+      <p:pic>
+        <p:nvPicPr>
+          <p:cNvPr id="10" name="Clip 1 v3" descr="img/v3_clip1.jpg">    </p:cNvPr>
+          <p:cNvPicPr>
+            <a:picLocks noChangeAspect="1"/>
+          </p:cNvPicPr>
+          <p:nvPr/>
+        </p:nvPicPr>
+        <p:blipFill>
+          <a:blip r:embed="rId2"/>
+          <a:srcRect l="0" r="0" t="0" b="0"/>
+          <a:stretch/>
+        </p:blipFill>
+        <p:spPr>
+          <a:xfrm>
+            <a:off x="457200" y="3108960"/>
+            <a:ext cx="868680" cy="1371600"/>
+          </a:xfrm>
+          <a:prstGeom prst="rect">
+            <a:avLst/>
+          </a:prstGeom>
+        </p:spPr>
+      </p:pic>
+      <p:sp>
+        <p:nvSpPr>
+          <p:cNvPr id="11" name="Text 6"/>
+          <p:cNvSpPr txBox="1"/>
+          <p:nvPr/>
+        </p:nvSpPr>
+        <p:spPr>
+          <a:xfrm>
+            <a:off x="1399032" y="3108960"/>
+            <a:ext cx="731520" cy="1371600"/>
+          </a:xfrm>
+          <a:prstGeom prst="rect">
+            <a:avLst/>
+          </a:prstGeom>
+          <a:noFill/>
+          <a:ln/>
+        </p:spPr>
+        <p:txBody>
+          <a:bodyPr wrap="square" lIns="0" tIns="0" rIns="0" bIns="0" rtlCol="0" anchor="t"/>
+          <a:lstStyle/>
+          <a:p>
+            <a:pPr indent="0" marL="0">
+              <a:buNone/>
+            </a:pPr>
+            <a:r>
+              <a:rPr lang="en-US" sz="900" b="1" dirty="0">
+                <a:solidFill>
+                  <a:srgbClr val="000000"/>
+                </a:solidFill>
+                <a:latin typeface="Verdana" pitchFamily="34" charset="0"/>
+                <a:ea typeface="Verdana" pitchFamily="34" charset="-122"/>
+                <a:cs typeface="Verdana" pitchFamily="34" charset="-120"/>
+              </a:rPr>
+              <a:t>#1 · min 16:11</a:t>
+            </a:r>
+            <a:endParaRPr lang="en-US" sz="900" dirty="0"/>
+          </a:p>
+          <a:p>
+            <a:pPr indent="0" marL="0">
+              <a:buNone/>
+            </a:pPr>
+            <a:r>
+              <a:rPr lang="en-US" sz="900" b="1" dirty="0">
+                <a:solidFill>
+                  <a:srgbClr val="2E7D32"/>
+                </a:solidFill>
+                <a:latin typeface="Verdana" pitchFamily="34" charset="0"/>
+                <a:ea typeface="Verdana" pitchFamily="34" charset="-122"/>
+                <a:cs typeface="Verdana" pitchFamily="34" charset="-120"/>
+              </a:rPr>
+              <a:t>score 85 · sobre pico</a:t>
+            </a:r>
+            <a:endParaRPr lang="en-US" sz="900" dirty="0"/>
+          </a:p>
+        </p:txBody>
+      </p:sp>
+      <p:pic>
+        <p:nvPicPr>
+          <p:cNvPr id="12" name="Clip 2 v3" descr="img/v3_clip2.jpg">    </p:cNvPr>
+          <p:cNvPicPr>
+            <a:picLocks noChangeAspect="1"/>
+          </p:cNvPicPr>
+          <p:nvPr/>
+        </p:nvPicPr>
+        <p:blipFill>
+          <a:blip r:embed="rId3"/>
+          <a:srcRect l="0" r="0" t="0" b="0"/>
+          <a:stretch/>
+        </p:blipFill>
+        <p:spPr>
+          <a:xfrm>
+            <a:off x="2103120" y="3108960"/>
+            <a:ext cx="868680" cy="1371600"/>
+          </a:xfrm>
+          <a:prstGeom prst="rect">
+            <a:avLst/>
+          </a:prstGeom>
+        </p:spPr>
+      </p:pic>
+      <p:sp>
+        <p:nvSpPr>
+          <p:cNvPr id="13" name="Text 7"/>
+          <p:cNvSpPr txBox="1"/>
+          <p:nvPr/>
+        </p:nvSpPr>
+        <p:spPr>
+          <a:xfrm>
+            <a:off x="3044952" y="3108960"/>
+            <a:ext cx="731520" cy="1371600"/>
+          </a:xfrm>
+          <a:prstGeom prst="rect">
+            <a:avLst/>
+          </a:prstGeom>
+          <a:noFill/>
+          <a:ln/>
+        </p:spPr>
+        <p:txBody>
+          <a:bodyPr wrap="square" lIns="0" tIns="0" rIns="0" bIns="0" rtlCol="0" anchor="t"/>
+          <a:lstStyle/>
+          <a:p>
+            <a:pPr indent="0" marL="0">
+              <a:buNone/>
+            </a:pPr>
+            <a:r>
+              <a:rPr lang="en-US" sz="900" b="1" dirty="0">
+                <a:solidFill>
+                  <a:srgbClr val="000000"/>
+                </a:solidFill>
+                <a:latin typeface="Verdana" pitchFamily="34" charset="0"/>
+                <a:ea typeface="Verdana" pitchFamily="34" charset="-122"/>
+                <a:cs typeface="Verdana" pitchFamily="34" charset="-120"/>
+              </a:rPr>
+              <a:t>#2 · min 7:19</a:t>
+            </a:r>
+            <a:endParaRPr lang="en-US" sz="900" dirty="0"/>
+          </a:p>
+          <a:p>
+            <a:pPr indent="0" marL="0">
+              <a:buNone/>
+            </a:pPr>
+            <a:r>
+              <a:rPr lang="en-US" sz="900" b="1" dirty="0">
+                <a:solidFill>
+                  <a:srgbClr val="2E7D32"/>
+                </a:solidFill>
+                <a:latin typeface="Verdana" pitchFamily="34" charset="0"/>
+                <a:ea typeface="Verdana" pitchFamily="34" charset="-122"/>
+                <a:cs typeface="Verdana" pitchFamily="34" charset="-120"/>
+              </a:rPr>
+              <a:t>score 65 · sobre pico</a:t>
+            </a:r>
+            <a:endParaRPr lang="en-US" sz="900" dirty="0"/>
+          </a:p>
+        </p:txBody>
+      </p:sp>
+      <p:pic>
+        <p:nvPicPr>
+          <p:cNvPr id="14" name="Clip 3 v3" descr="img/v3_clip3.jpg">    </p:cNvPr>
+          <p:cNvPicPr>
+            <a:picLocks noChangeAspect="1"/>
+          </p:cNvPicPr>
+          <p:nvPr/>
+        </p:nvPicPr>
+        <p:blipFill>
+          <a:blip r:embed="rId4"/>
+          <a:srcRect l="0" r="0" t="0" b="0"/>
+          <a:stretch/>
+        </p:blipFill>
+        <p:spPr>
+          <a:xfrm>
+            <a:off x="3749040" y="3108960"/>
+            <a:ext cx="868680" cy="1371600"/>
+          </a:xfrm>
+          <a:prstGeom prst="rect">
+            <a:avLst/>
+          </a:prstGeom>
+        </p:spPr>
+      </p:pic>
+      <p:sp>
+        <p:nvSpPr>
+          <p:cNvPr id="15" name="Text 8"/>
+          <p:cNvSpPr txBox="1"/>
+          <p:nvPr/>
+        </p:nvSpPr>
+        <p:spPr>
+          <a:xfrm>
+            <a:off x="4690872" y="3108960"/>
+            <a:ext cx="731520" cy="1371600"/>
+          </a:xfrm>
+          <a:prstGeom prst="rect">
+            <a:avLst/>
+          </a:prstGeom>
+          <a:noFill/>
+          <a:ln/>
+        </p:spPr>
+        <p:txBody>
+          <a:bodyPr wrap="square" lIns="0" tIns="0" rIns="0" bIns="0" rtlCol="0" anchor="t"/>
+          <a:lstStyle/>
+          <a:p>
+            <a:pPr indent="0" marL="0">
+              <a:buNone/>
+            </a:pPr>
+            <a:r>
+              <a:rPr lang="en-US" sz="900" b="1" dirty="0">
+                <a:solidFill>
+                  <a:srgbClr val="000000"/>
+                </a:solidFill>
+                <a:latin typeface="Verdana" pitchFamily="34" charset="0"/>
+                <a:ea typeface="Verdana" pitchFamily="34" charset="-122"/>
+                <a:cs typeface="Verdana" pitchFamily="34" charset="-120"/>
+              </a:rPr>
+              <a:t>#3 · min 21:08</a:t>
+            </a:r>
+            <a:endParaRPr lang="en-US" sz="900" dirty="0"/>
+          </a:p>
+          <a:p>
+            <a:pPr indent="0" marL="0">
+              <a:buNone/>
+            </a:pPr>
+            <a:r>
+              <a:rPr lang="en-US" sz="900" dirty="0">
+                <a:solidFill>
+                  <a:srgbClr val="595959"/>
+                </a:solidFill>
+                <a:latin typeface="Verdana" pitchFamily="34" charset="0"/>
+                <a:ea typeface="Verdana" pitchFamily="34" charset="-122"/>
+                <a:cs typeface="Verdana" pitchFamily="34" charset="-120"/>
+              </a:rPr>
+              <a:t>score 56 · fuera</a:t>
+            </a:r>
+            <a:endParaRPr lang="en-US" sz="900" dirty="0"/>
+          </a:p>
+        </p:txBody>
+      </p:sp>
+      <p:pic>
+        <p:nvPicPr>
+          <p:cNvPr id="16" name="Clip 4 v3" descr="img/v3_clip4.jpg">    </p:cNvPr>
+          <p:cNvPicPr>
+            <a:picLocks noChangeAspect="1"/>
+          </p:cNvPicPr>
+          <p:nvPr/>
+        </p:nvPicPr>
+        <p:blipFill>
+          <a:blip r:embed="rId5"/>
+          <a:srcRect l="0" r="0" t="0" b="0"/>
+          <a:stretch/>
+        </p:blipFill>
+        <p:spPr>
+          <a:xfrm>
+            <a:off x="5394960" y="3108960"/>
+            <a:ext cx="868680" cy="1371600"/>
+          </a:xfrm>
+          <a:prstGeom prst="rect">
+            <a:avLst/>
+          </a:prstGeom>
+        </p:spPr>
+      </p:pic>
+      <p:sp>
+        <p:nvSpPr>
+          <p:cNvPr id="17" name="Text 9"/>
+          <p:cNvSpPr txBox="1"/>
+          <p:nvPr/>
+        </p:nvSpPr>
+        <p:spPr>
+          <a:xfrm>
+            <a:off x="6336792" y="3108960"/>
+            <a:ext cx="731520" cy="1371600"/>
+          </a:xfrm>
+          <a:prstGeom prst="rect">
+            <a:avLst/>
+          </a:prstGeom>
+          <a:noFill/>
+          <a:ln/>
+        </p:spPr>
+        <p:txBody>
+          <a:bodyPr wrap="square" lIns="0" tIns="0" rIns="0" bIns="0" rtlCol="0" anchor="t"/>
+          <a:lstStyle/>
+          <a:p>
+            <a:pPr indent="0" marL="0">
+              <a:buNone/>
+            </a:pPr>
+            <a:r>
+              <a:rPr lang="en-US" sz="900" b="1" dirty="0">
+                <a:solidFill>
+                  <a:srgbClr val="000000"/>
+                </a:solidFill>
+                <a:latin typeface="Verdana" pitchFamily="34" charset="0"/>
+                <a:ea typeface="Verdana" pitchFamily="34" charset="-122"/>
+                <a:cs typeface="Verdana" pitchFamily="34" charset="-120"/>
+              </a:rPr>
+              <a:t>#4 · min 9:19</a:t>
+            </a:r>
+            <a:endParaRPr lang="en-US" sz="900" dirty="0"/>
+          </a:p>
+          <a:p>
+            <a:pPr indent="0" marL="0">
+              <a:buNone/>
+            </a:pPr>
+            <a:r>
+              <a:rPr lang="en-US" sz="900" b="1" dirty="0">
+                <a:solidFill>
+                  <a:srgbClr val="2E7D32"/>
+                </a:solidFill>
+                <a:latin typeface="Verdana" pitchFamily="34" charset="0"/>
+                <a:ea typeface="Verdana" pitchFamily="34" charset="-122"/>
+                <a:cs typeface="Verdana" pitchFamily="34" charset="-120"/>
+              </a:rPr>
+              <a:t>score 37 · sobre pico</a:t>
+            </a:r>
+            <a:endParaRPr lang="en-US" sz="900" dirty="0"/>
+          </a:p>
+        </p:txBody>
+      </p:sp>
+      <p:pic>
+        <p:nvPicPr>
+          <p:cNvPr id="18" name="Clip 5 v3" descr="img/v3_clip5.jpg">    </p:cNvPr>
+          <p:cNvPicPr>
+            <a:picLocks noChangeAspect="1"/>
+          </p:cNvPicPr>
+          <p:nvPr/>
+        </p:nvPicPr>
+        <p:blipFill>
+          <a:blip r:embed="rId6"/>
+          <a:srcRect l="0" r="0" t="0" b="0"/>
+          <a:stretch/>
+        </p:blipFill>
+        <p:spPr>
+          <a:xfrm>
+            <a:off x="7040880" y="3108960"/>
+            <a:ext cx="868680" cy="1371600"/>
+          </a:xfrm>
+          <a:prstGeom prst="rect">
+            <a:avLst/>
+          </a:prstGeom>
+        </p:spPr>
+      </p:pic>
+      <p:sp>
+        <p:nvSpPr>
+          <p:cNvPr id="19" name="Text 10"/>
+          <p:cNvSpPr txBox="1"/>
+          <p:nvPr/>
+        </p:nvSpPr>
+        <p:spPr>
+          <a:xfrm>
+            <a:off x="7982712" y="3108960"/>
+            <a:ext cx="731520" cy="1371600"/>
+          </a:xfrm>
+          <a:prstGeom prst="rect">
+            <a:avLst/>
+          </a:prstGeom>
+          <a:noFill/>
+          <a:ln/>
+        </p:spPr>
+        <p:txBody>
+          <a:bodyPr wrap="square" lIns="0" tIns="0" rIns="0" bIns="0" rtlCol="0" anchor="t"/>
+          <a:lstStyle/>
+          <a:p>
+            <a:pPr indent="0" marL="0">
+              <a:buNone/>
+            </a:pPr>
+            <a:r>
+              <a:rPr lang="en-US" sz="900" b="1" dirty="0">
+                <a:solidFill>
+                  <a:srgbClr val="000000"/>
+                </a:solidFill>
+                <a:latin typeface="Verdana" pitchFamily="34" charset="0"/>
+                <a:ea typeface="Verdana" pitchFamily="34" charset="-122"/>
+                <a:cs typeface="Verdana" pitchFamily="34" charset="-120"/>
+              </a:rPr>
+              <a:t>#5 · min 20:30</a:t>
+            </a:r>
+            <a:endParaRPr lang="en-US" sz="900" dirty="0"/>
+          </a:p>
+          <a:p>
+            <a:pPr indent="0" marL="0">
+              <a:buNone/>
+            </a:pPr>
+            <a:r>
+              <a:rPr lang="en-US" sz="900" dirty="0">
+                <a:solidFill>
+                  <a:srgbClr val="595959"/>
+                </a:solidFill>
+                <a:latin typeface="Verdana" pitchFamily="34" charset="0"/>
+                <a:ea typeface="Verdana" pitchFamily="34" charset="-122"/>
+                <a:cs typeface="Verdana" pitchFamily="34" charset="-120"/>
+              </a:rPr>
+              <a:t>score 34 · fuera</a:t>
+            </a:r>
+            <a:endParaRPr lang="en-US" sz="900" dirty="0"/>
+          </a:p>
+        </p:txBody>
+      </p:sp>
+      <p:sp>
+        <p:nvSpPr>
+          <p:cNvPr id="20" name="Text 11"/>
+          <p:cNvSpPr txBox="1"/>
+          <p:nvPr/>
+        </p:nvSpPr>
+        <p:spPr>
+          <a:xfrm>
+            <a:off x="4937760" y="1051560"/>
+            <a:ext cx="3657600" cy="228600"/>
+          </a:xfrm>
+          <a:prstGeom prst="rect">
+            <a:avLst/>
+          </a:prstGeom>
+          <a:noFill/>
+          <a:ln/>
+        </p:spPr>
+        <p:txBody>
+          <a:bodyPr wrap="square" lIns="0" tIns="0" rIns="0" bIns="0" rtlCol="0" anchor="ctr"/>
+          <a:lstStyle/>
+          <a:p>
+            <a:pPr algn="r" indent="0" marL="0">
+              <a:buNone/>
+            </a:pPr>
+            <a:r>
+              <a:rPr lang="en-US" sz="1100" b="1" dirty="0">
+                <a:solidFill>
+                  <a:srgbClr val="2E7D32"/>
+                </a:solidFill>
+                <a:latin typeface="Verdana" pitchFamily="34" charset="0"/>
+                <a:ea typeface="Verdana" pitchFamily="34" charset="-122"/>
+                <a:cs typeface="Verdana" pitchFamily="34" charset="-120"/>
+              </a:rPr>
+              <a:t>3 de 5 clips sobre un pico real</a:t>
+            </a:r>
+            <a:endParaRPr lang="en-US" sz="1100" dirty="0"/>
+          </a:p>
+        </p:txBody>
+      </p:sp>
+    </p:spTree>
+  </p:cSld>
+  <p:clrMapOvr>
+    <a:masterClrMapping/>
+  </p:clrMapOvr>
+</p:sld>
+</file>
+
+<file path=ppt/slides/slide17.xml><?xml version="1.0" encoding="utf-8"?>
+<p:sld xmlns:a="http://schemas.openxmlformats.org/drawingml/2006/main" xmlns:r="http://schemas.openxmlformats.org/officeDocument/2006/relationships" xmlns:p="http://schemas.openxmlformats.org/presentationml/2006/main">
+  <p:cSld name="Slide 17">
+    <p:bg>
+      <p:bgPr>
+        <a:solidFill>
+          <a:srgbClr val="FFFFFF"/>
+        </a:solidFill>
+      </p:bgPr>
+    </p:bg>
+    <p:spTree>
+      <p:nvGrpSpPr>
+        <p:cNvPr id="1" name=""/>
+        <p:cNvGrpSpPr/>
+        <p:nvPr/>
+      </p:nvGrpSpPr>
+      <p:grpSpPr>
+        <a:xfrm>
+          <a:off x="0" y="0"/>
+          <a:ext cx="0" cy="0"/>
+          <a:chOff x="0" y="0"/>
+          <a:chExt cx="0" cy="0"/>
+        </a:xfrm>
+      </p:grpSpPr>
+      <p:sp>
+        <p:nvSpPr>
+          <p:cNvPr id="2" name="Shape 0"/>
+          <p:cNvSpPr/>
+          <p:nvPr/>
+        </p:nvSpPr>
+        <p:spPr>
+          <a:xfrm>
+            <a:off x="8412480" y="256032"/>
+            <a:ext cx="274320" cy="274320"/>
+          </a:xfrm>
+          <a:prstGeom prst="star5">
+            <a:avLst/>
+          </a:prstGeom>
+          <a:solidFill>
+            <a:srgbClr val="FF4713"/>
+          </a:solidFill>
+          <a:ln w="12700">
+            <a:solidFill>
+              <a:srgbClr val="FF4713"/>
+            </a:solidFill>
+            <a:prstDash val="solid"/>
+          </a:ln>
+        </p:spPr>
+      </p:sp>
+      <p:sp>
+        <p:nvSpPr>
+          <p:cNvPr id="3" name="Text 1"/>
+          <p:cNvSpPr txBox="1"/>
+          <p:nvPr/>
+        </p:nvSpPr>
+        <p:spPr>
+          <a:xfrm>
+            <a:off x="457200" y="228600"/>
+            <a:ext cx="7315200" cy="274320"/>
+          </a:xfrm>
+          <a:prstGeom prst="rect">
+            <a:avLst/>
+          </a:prstGeom>
+          <a:noFill/>
+          <a:ln/>
+        </p:spPr>
+        <p:txBody>
+          <a:bodyPr wrap="square" lIns="0" tIns="0" rIns="0" bIns="0" rtlCol="0" anchor="ctr"/>
+          <a:lstStyle/>
+          <a:p>
+            <a:pPr indent="0" marL="0">
+              <a:buNone/>
+            </a:pPr>
+            <a:r>
+              <a:rPr lang="en-US" sz="1100" b="1" dirty="0">
+                <a:solidFill>
+                  <a:srgbClr val="FF4713"/>
+                </a:solidFill>
+                <a:latin typeface="Verdana" pitchFamily="34" charset="0"/>
+                <a:ea typeface="Verdana" pitchFamily="34" charset="-122"/>
+                <a:cs typeface="Verdana" pitchFamily="34" charset="-120"/>
+              </a:rPr>
+              <a:t>6 · ALCANCE Y SIGUIENTES PASOS</a:t>
+            </a:r>
+            <a:endParaRPr lang="en-US" sz="1100" dirty="0"/>
+          </a:p>
+        </p:txBody>
+      </p:sp>
+      <p:sp>
+        <p:nvSpPr>
+          <p:cNvPr id="4" name="Text 2"/>
+          <p:cNvSpPr txBox="1"/>
+          <p:nvPr/>
+        </p:nvSpPr>
+        <p:spPr>
+          <a:xfrm>
+            <a:off x="457200" y="548640"/>
+            <a:ext cx="8046720" cy="548640"/>
+          </a:xfrm>
+          <a:prstGeom prst="rect">
+            <a:avLst/>
+          </a:prstGeom>
+          <a:noFill/>
+          <a:ln/>
+        </p:spPr>
+        <p:txBody>
+          <a:bodyPr wrap="square" lIns="0" tIns="0" rIns="0" bIns="0" rtlCol="0" anchor="ctr"/>
+          <a:lstStyle/>
+          <a:p>
+            <a:pPr indent="0" marL="0">
+              <a:buNone/>
+            </a:pPr>
+            <a:r>
+              <a:rPr lang="en-US" sz="2200" b="1" dirty="0">
+                <a:solidFill>
+                  <a:srgbClr val="000000"/>
+                </a:solidFill>
+                <a:latin typeface="Verdana" pitchFamily="34" charset="0"/>
+                <a:ea typeface="Verdana" pitchFamily="34" charset="-122"/>
+                <a:cs typeface="Verdana" pitchFamily="34" charset="-120"/>
+              </a:rPr>
+              <a:t>Qué se logró y qué falta</a:t>
+            </a:r>
+            <a:endParaRPr lang="en-US" sz="2200" dirty="0"/>
+          </a:p>
+        </p:txBody>
+      </p:sp>
+      <p:sp>
+        <p:nvSpPr>
+          <p:cNvPr id="5" name="Shape 3"/>
+          <p:cNvSpPr/>
+          <p:nvPr/>
+        </p:nvSpPr>
+        <p:spPr>
+          <a:xfrm>
+            <a:off x="457200" y="1143000"/>
+            <a:ext cx="731520" cy="36576"/>
+          </a:xfrm>
+          <a:prstGeom prst="rect">
+            <a:avLst/>
+          </a:prstGeom>
+          <a:solidFill>
+            <a:srgbClr val="FF4713"/>
+          </a:solidFill>
+          <a:ln w="12700">
+            <a:solidFill>
+              <a:srgbClr val="FF4713"/>
+            </a:solidFill>
+            <a:prstDash val="solid"/>
+          </a:ln>
+        </p:spPr>
+      </p:sp>
+      <p:sp>
+        <p:nvSpPr>
+          <p:cNvPr id="6" name="Text 4"/>
+          <p:cNvSpPr txBox="1"/>
+          <p:nvPr/>
+        </p:nvSpPr>
+        <p:spPr>
+          <a:xfrm>
+            <a:off x="457200" y="4800600"/>
+            <a:ext cx="5486400" cy="228600"/>
+          </a:xfrm>
+          <a:prstGeom prst="rect">
+            <a:avLst/>
+          </a:prstGeom>
+          <a:noFill/>
+          <a:ln/>
+        </p:spPr>
+        <p:txBody>
+          <a:bodyPr wrap="square" lIns="0" tIns="0" rIns="0" bIns="0" rtlCol="0" anchor="ctr"/>
+          <a:lstStyle/>
+          <a:p>
+            <a:pPr indent="0" marL="0">
+              <a:buNone/>
+            </a:pPr>
+            <a:r>
+              <a:rPr lang="en-US" sz="1000" dirty="0">
+                <a:solidFill>
+                  <a:srgbClr val="595959"/>
+                </a:solidFill>
+                <a:latin typeface="Verdana" pitchFamily="34" charset="0"/>
+                <a:ea typeface="Verdana" pitchFamily="34" charset="-122"/>
+                <a:cs typeface="Verdana" pitchFamily="34" charset="-120"/>
+              </a:rPr>
+              <a:t>Seminario de Investigación I · 2026-2</a:t>
+            </a:r>
+            <a:endParaRPr lang="en-US" sz="1000" dirty="0"/>
+          </a:p>
+        </p:txBody>
+      </p:sp>
+      <p:sp>
+        <p:nvSpPr>
+          <p:cNvPr id="7" name="Text 5"/>
+          <p:cNvSpPr txBox="1"/>
+          <p:nvPr/>
+        </p:nvSpPr>
+        <p:spPr>
+          <a:xfrm>
+            <a:off x="8229600" y="4800600"/>
+            <a:ext cx="457200" cy="228600"/>
+          </a:xfrm>
+          <a:prstGeom prst="rect">
+            <a:avLst/>
+          </a:prstGeom>
+          <a:noFill/>
+          <a:ln/>
+        </p:spPr>
+        <p:txBody>
+          <a:bodyPr wrap="square" lIns="0" tIns="0" rIns="0" bIns="0" rtlCol="0" anchor="ctr"/>
+          <a:lstStyle/>
+          <a:p>
+            <a:pPr algn="r" indent="0" marL="0">
+              <a:buNone/>
+            </a:pPr>
+            <a:r>
+              <a:rPr lang="en-US" sz="1000" dirty="0">
+                <a:solidFill>
+                  <a:srgbClr val="595959"/>
+                </a:solidFill>
+                <a:latin typeface="Verdana" pitchFamily="34" charset="0"/>
+                <a:ea typeface="Verdana" pitchFamily="34" charset="-122"/>
+                <a:cs typeface="Verdana" pitchFamily="34" charset="-120"/>
+              </a:rPr>
+              <a:t>17</a:t>
             </a:r>
             <a:endParaRPr lang="en-US" sz="1000" dirty="0"/>
           </a:p>

</xml_diff>